<commit_message>
F2T: revise all 28 lessons to the validated model with short bulleted points
Only the points of the progression sheet, definitions in a separate block,
one short sentence per bulleted point, pictures beside key points,
situations ending with the character's question, one question per slide.

Co-Authored-By: Claude Opus 5.5 <noreply@anthropic.com>
Claude-Session: https://claude.ai/code/session_0115LFSb2ktGLWPeVksFkSer
</commit_message>
<xml_diff>
--- a/lecons/F2T/01_F2T_L1_P1_Equatorial_Location_Climate.pptx
+++ b/lecons/F2T/01_F2T_L1_P1_Equatorial_Location_Climate.pptx
@@ -56,12 +56,9 @@
     <p:sldId id="304" r:id="rId50"/>
     <p:sldId id="305" r:id="rId51"/>
     <p:sldId id="306" r:id="rId52"/>
-    <p:sldId id="307" r:id="rId53"/>
-    <p:sldId id="308" r:id="rId54"/>
-    <p:sldId id="309" r:id="rId55"/>
   </p:sldIdLst>
   <p:notesMasterIdLst>
-    <p:notesMasterId r:id="rId56"/>
+    <p:notesMasterId r:id="rId53"/>
   </p:notesMasterIdLst>
   <p:sldSz cx="12192000" cy="6858000"/>
   <p:notesSz cx="6858000" cy="12192000"/>
@@ -643,7 +640,7 @@
           <a:p>
             <a:r>
               <a:rPr lang="en-US" dirty="0"/>
-              <a:t>Good. Nadia does not understand why it rains in almost every month in Yaoundé.</a:t>
+              <a:t>Good. Nadia does not know why Yaoundé is wet all year while Garoua has a long dry season.</a:t>
             </a:r>
             <a:endParaRPr lang="en-US" dirty="0"/>
           </a:p>
@@ -819,7 +816,7 @@
           <a:p>
             <a:r>
               <a:rPr lang="en-US" dirty="0"/>
-              <a:t>Good. It is hot and wet, with rain in almost every month.</a:t>
+              <a:t>Good. It rains in almost every month and the air is wet.</a:t>
             </a:r>
             <a:endParaRPr lang="en-US" dirty="0"/>
           </a:p>
@@ -907,7 +904,7 @@
           <a:p>
             <a:r>
               <a:rPr lang="en-US" dirty="0"/>
-              <a:t>Question 3: Why is Yaoundé wetter than Garoua? Think for a moment, then raise your hand to answer.</a:t>
+              <a:t>Question 3: In which natural region is Yaoundé? Think for a moment, then raise your hand to answer.</a:t>
             </a:r>
             <a:endParaRPr lang="en-US" dirty="0"/>
           </a:p>
@@ -995,7 +992,7 @@
           <a:p>
             <a:r>
               <a:rPr lang="en-US" dirty="0"/>
-              <a:t>Good. Yaoundé is closer to the Equator, in the Equatorial region.</a:t>
+              <a:t>Good. In the Equatorial region.</a:t>
             </a:r>
             <a:endParaRPr lang="en-US" dirty="0"/>
           </a:p>
@@ -1259,7 +1256,7 @@
           <a:p>
             <a:r>
               <a:rPr lang="en-US" dirty="0"/>
-              <a:t>Activity 1. Look carefully at this picture: a thick forest near the Equator. Observe every detail before I ask the question.</a:t>
+              <a:t>Activity 1. Look carefully at this picture: a thick forest. Observe every detail before I ask the question.</a:t>
             </a:r>
             <a:endParaRPr lang="en-US" dirty="0"/>
           </a:p>
@@ -1347,7 +1344,7 @@
           <a:p>
             <a:r>
               <a:rPr lang="en-US" dirty="0"/>
-              <a:t>Here is the question for Activity 1: Describe the vegetation in the picture. In which natural region do we find it? Take one minute to think and write your answer in your rough notebook.</a:t>
+              <a:t>Here is the question for Activity 1: In which natural region do we find this thick, green forest? Take one minute to think and write your answer in your rough notebook.</a:t>
             </a:r>
             <a:endParaRPr lang="en-US" dirty="0"/>
           </a:p>
@@ -1435,7 +1432,7 @@
           <a:p>
             <a:r>
               <a:rPr lang="en-US" dirty="0"/>
-              <a:t>Let us check the answer together. It is a thick, green forest with tall trees close together. We find it in the Equatorial region.</a:t>
+              <a:t>Let us check the answer together. In the Equatorial region.</a:t>
             </a:r>
             <a:endParaRPr lang="en-US" dirty="0"/>
           </a:p>
@@ -1699,7 +1696,7 @@
           <a:p>
             <a:r>
               <a:rPr lang="en-US" dirty="0"/>
-              <a:t>Here is the question for Activity 2: Between which latitudes is the Equatorial region found? Name three areas. Take one minute to think and write your answer in your rough notebook.</a:t>
+              <a:t>Here is the question for Activity 2: Between which latitudes is the Equatorial region found? Take one minute to think and write your answer in your rough notebook.</a:t>
             </a:r>
             <a:endParaRPr lang="en-US" dirty="0"/>
           </a:p>
@@ -1787,7 +1784,7 @@
           <a:p>
             <a:r>
               <a:rPr lang="en-US" dirty="0"/>
-              <a:t>Let us check the answer together. Between about 5° N and 5° S of the Equator: the Amazon Basin, the Congo Basin and South-East Asia.</a:t>
+              <a:t>Let us check the answer together. Between about 5° N and 5° S of the Equator.</a:t>
             </a:r>
             <a:endParaRPr lang="en-US" dirty="0"/>
           </a:p>
@@ -1875,7 +1872,7 @@
           <a:p>
             <a:r>
               <a:rPr lang="en-US" dirty="0"/>
-              <a:t>Activity 3. Look carefully at this diagram: the climate of Yaoundé: rain (blue bars) and temperature (red line). Observe every detail before I ask the question.</a:t>
+              <a:t>Activity 3. Look carefully at this diagram: the climate of Yaoundé. Observe every detail before I ask the question.</a:t>
             </a:r>
             <a:endParaRPr lang="en-US" dirty="0"/>
           </a:p>
@@ -1963,7 +1960,7 @@
           <a:p>
             <a:r>
               <a:rPr lang="en-US" dirty="0"/>
-              <a:t>Here is the question for Activity 3: Look at the red line. Is Yaoundé hot or cold? Does the temperature change much during the year? Take one minute to think and write your answer in your rough notebook.</a:t>
+              <a:t>Here is the question for Activity 3: Look at the red line. Is Yaoundé hot or cold during the year? Take one minute to think and write your answer in your rough notebook.</a:t>
             </a:r>
             <a:endParaRPr lang="en-US" dirty="0"/>
           </a:p>
@@ -2051,7 +2048,7 @@
           <a:p>
             <a:r>
               <a:rPr lang="en-US" dirty="0"/>
-              <a:t>Let us check the answer together. It is hot all year, about 23 °C to 25 °C. The temperature changes very little, so the annual range is small.</a:t>
+              <a:t>Let us check the answer together. It is hot all year, about 23 °C to 25 °C.</a:t>
             </a:r>
             <a:endParaRPr lang="en-US" dirty="0"/>
           </a:p>
@@ -2139,7 +2136,7 @@
           <a:p>
             <a:r>
               <a:rPr lang="en-US" dirty="0"/>
-              <a:t>Activity 4. Look carefully at this diagram: the climate of Yaoundé: two rainy seasons. Observe every detail before I ask the question.</a:t>
+              <a:t>Activity 4. Look carefully at this diagram: the climate of Yaoundé. Observe every detail before I ask the question.</a:t>
             </a:r>
             <a:endParaRPr lang="en-US" dirty="0"/>
           </a:p>
@@ -2227,7 +2224,7 @@
           <a:p>
             <a:r>
               <a:rPr lang="en-US" dirty="0"/>
-              <a:t>Here is the question for Activity 4: Look at the blue bars. Does it rain in every month? How many rainy seasons are there? Take one minute to think and write your answer in your rough notebook.</a:t>
+              <a:t>Here is the question for Activity 4: Look at the blue bars. Does it rain in every month? Take one minute to think and write your answer in your rough notebook.</a:t>
             </a:r>
             <a:endParaRPr lang="en-US" dirty="0"/>
           </a:p>
@@ -2315,7 +2312,7 @@
           <a:p>
             <a:r>
               <a:rPr lang="en-US" dirty="0"/>
-              <a:t>Let us check the answer together. It rains in almost every month. There are two rainy seasons, with the heaviest rains in May and in October.</a:t>
+              <a:t>Let us check the answer together. Yes, it rains in almost every month.</a:t>
             </a:r>
             <a:endParaRPr lang="en-US" dirty="0"/>
           </a:p>
@@ -2403,7 +2400,7 @@
           <a:p>
             <a:r>
               <a:rPr lang="en-US" dirty="0"/>
-              <a:t>Activity 5. Look carefully at this picture: a big storm cloud in the afternoon. Observe every detail before I ask the question.</a:t>
+              <a:t>Activity 5. Look carefully at this picture: a storm. Observe every detail before I ask the question.</a:t>
             </a:r>
             <a:endParaRPr lang="en-US" dirty="0"/>
           </a:p>
@@ -2579,7 +2576,7 @@
           <a:p>
             <a:r>
               <a:rPr lang="en-US" dirty="0"/>
-              <a:t>Here is the question for Activity 5: In the Equatorial region, heavy rain often falls in the afternoon. Why? Take one minute to think and write your answer in your rough notebook.</a:t>
+              <a:t>Here is the question for Activity 5: At what time of the day does heavy rain often fall in the Equatorial region? Take one minute to think and write your answer in your rough notebook.</a:t>
             </a:r>
             <a:endParaRPr lang="en-US" dirty="0"/>
           </a:p>
@@ -2667,7 +2664,7 @@
           <a:p>
             <a:r>
               <a:rPr lang="en-US" dirty="0"/>
-              <a:t>Let us check the answer together. The hot sun heats the wet air in the morning. The air rises, cools and forms big clouds that give heavy rain with thunder in the afternoon: this is convectional rain.</a:t>
+              <a:t>Let us check the answer together. In the afternoon, after the sun has heated the air.</a:t>
             </a:r>
             <a:endParaRPr lang="en-US" dirty="0"/>
           </a:p>
@@ -2843,7 +2840,7 @@
           <a:p>
             <a:r>
               <a:rPr lang="en-US" dirty="0"/>
-              <a:t>Let us copy Meaning. The Equatorial region is defined as follows. On this slide we have Equatorial region. Write each point on a new line, with the key term first, and explain it in your own words when we revise.</a:t>
+              <a:t>Let us copy the definitions. The key terms of this lesson are defined as follows. On this slide we have Equatorial region and Climate. Write each point on a new line, with the key term first, and explain it in your own words when we revise.</a:t>
             </a:r>
             <a:endParaRPr lang="en-US" dirty="0"/>
           </a:p>
@@ -2931,7 +2928,7 @@
           <a:p>
             <a:r>
               <a:rPr lang="en-US" dirty="0"/>
-              <a:t>Let us copy Location. The Equatorial region lies between about 5° N and 5° S of the Equator. On this slide we have Africa and South America. Write each point on a new line, with the key term first, and explain it in your own words when we revise. When you finish, we go to the next slide.</a:t>
+              <a:t>Let us copy Location. The Equatorial region lies between 5° N and 5° S. Copy the point on Africa on the left, then draw the diagram on the right: the Equatorial regions of the world. Give it a title and label it clearly.</a:t>
             </a:r>
             <a:endParaRPr lang="en-US" dirty="0"/>
           </a:p>
@@ -3019,7 +3016,7 @@
           <a:p>
             <a:r>
               <a:rPr lang="en-US" dirty="0"/>
-              <a:t>We continue with Location. On this slide we have Asia. Write each point on a new line, with the key term first, and explain it in your own words when we revise.</a:t>
+              <a:t>We continue with Location. On this slide we have South America and Asia. Write each point on a new line, with the key term first, and explain it in your own words when we revise.</a:t>
             </a:r>
             <a:endParaRPr lang="en-US" dirty="0"/>
           </a:p>
@@ -3107,7 +3104,7 @@
           <a:p>
             <a:r>
               <a:rPr lang="en-US" dirty="0"/>
-              <a:t>Now draw this illustration in your notebook: the Equatorial regions of the world. Give it a title and label it clearly.</a:t>
+              <a:t>Let us copy Characteristics of the Climate. The equatorial climate has the following characteristics. Copy the point on Hot all year on the left, then draw the diagram on the right: the climate of Yaoundé. Give it a title and label it clearly.</a:t>
             </a:r>
             <a:endParaRPr lang="en-US" dirty="0"/>
           </a:p>
@@ -3195,7 +3192,7 @@
           <a:p>
             <a:r>
               <a:rPr lang="en-US" dirty="0"/>
-              <a:t>Let us copy Characteristics of the Climate. The equatorial climate has the following characteristics. On this slide we have Temperature and Annual range. Write each point on a new line, with the key term first, and explain it in your own words when we revise. When you finish, we go to the next slide.</a:t>
+              <a:t>We continue with Characteristics of the Climate. On this slide we have Small annual range, Heavy rain and Afternoon storms. Write each point on a new line, with the key term first, and explain it in your own words when we revise. When you finish, we go to the next slide.</a:t>
             </a:r>
             <a:endParaRPr lang="en-US" dirty="0"/>
           </a:p>
@@ -3283,7 +3280,7 @@
           <a:p>
             <a:r>
               <a:rPr lang="en-US" dirty="0"/>
-              <a:t>We continue with Characteristics of the Climate. On this slide we have Rainfall and Convectional rain. Write each point on a new line, with the key term first, and explain it in your own words when we revise. When you finish, we go to the next slide.</a:t>
+              <a:t>We continue with Characteristics of the Climate. On this slide we have High humidity. Write each point on a new line, with the key term first, and explain it in your own words when we revise.</a:t>
             </a:r>
             <a:endParaRPr lang="en-US" dirty="0"/>
           </a:p>
@@ -3371,7 +3368,7 @@
           <a:p>
             <a:r>
               <a:rPr lang="en-US" dirty="0"/>
-              <a:t>We continue with Characteristics of the Climate. On this slide we have Humidity. Write each point on a new line, with the key term first, and explain it in your own words when we revise.</a:t>
+              <a:t>Now let us check what you have understood. Question 1: Between which latitudes is the Equatorial region found? Answer in your exercise book.</a:t>
             </a:r>
             <a:endParaRPr lang="en-US" dirty="0"/>
           </a:p>
@@ -3547,7 +3544,7 @@
           <a:p>
             <a:r>
               <a:rPr lang="en-US" dirty="0"/>
-              <a:t>Now draw this illustration in your notebook: the climate of Yaoundé. Give it a title and label it clearly.</a:t>
+              <a:t>The expected answer is: between about 5° N and 5° S of the Equator. If you got it right, well done.</a:t>
             </a:r>
             <a:endParaRPr lang="en-US" dirty="0"/>
           </a:p>
@@ -3635,7 +3632,7 @@
           <a:p>
             <a:r>
               <a:rPr lang="en-US" dirty="0"/>
-              <a:t>Now let us check what you have understood. Question 1: Between which latitudes is the Equatorial region found? Answer in your exercise book.</a:t>
+              <a:t>Now let us check what you have understood. Question 2: Give two characteristics of the equatorial climate. Answer in your exercise book.</a:t>
             </a:r>
             <a:endParaRPr lang="en-US" dirty="0"/>
           </a:p>
@@ -3723,7 +3720,7 @@
           <a:p>
             <a:r>
               <a:rPr lang="en-US" dirty="0"/>
-              <a:t>The expected answer is: between about 5° N and 5° S of the Equator. If you got it right, well done.</a:t>
+              <a:t>The expected answer is: it is hot all year (about 25 °C) and it rains in almost every month. If you got it right, well done.</a:t>
             </a:r>
             <a:endParaRPr lang="en-US" dirty="0"/>
           </a:p>
@@ -3811,7 +3808,7 @@
           <a:p>
             <a:r>
               <a:rPr lang="en-US" dirty="0"/>
-              <a:t>Now let us check what you have understood. Question 2: Give two characteristics of the equatorial climate. Answer in your exercise book.</a:t>
+              <a:t>Take your time to copy this part; we will continue together.</a:t>
             </a:r>
             <a:endParaRPr lang="en-US" dirty="0"/>
           </a:p>
@@ -3899,7 +3896,7 @@
           <a:p>
             <a:r>
               <a:rPr lang="en-US" dirty="0"/>
-              <a:t>The expected answer is: it is hot all year (about 25 °C) and it rains in almost every month. If you got it right, well done.</a:t>
+              <a:t>For those who need more practice, fill in the blanks in your exercise book. The answers are: number 1, Equator; number 2, convectional; number 3, range.</a:t>
             </a:r>
             <a:endParaRPr lang="en-US" dirty="0"/>
           </a:p>
@@ -3987,7 +3984,7 @@
           <a:p>
             <a:r>
               <a:rPr lang="en-US" dirty="0"/>
-              <a:t>Take your time to copy this part; we will continue together.</a:t>
+              <a:t>For your homework: Ask someone who has lived in Yaoundé, Douala or Bertoua to describe the trees and plants around the town. Write three things he or she says. We shall correct it at the beginning of our next lesson.</a:t>
             </a:r>
             <a:endParaRPr lang="en-US" dirty="0"/>
           </a:p>
@@ -4075,7 +4072,7 @@
           <a:p>
             <a:r>
               <a:rPr lang="en-US" dirty="0"/>
-              <a:t>For those who need more practice, fill in the blanks in your exercise book. The answers are: number 1, Equator; number 2, convectional; number 3, range.</a:t>
+              <a:t>Our next lesson will be on Lesson 1 (Part 2): The Equatorial Region: Characteristics (Soils and Vegetation). Thank you for your attention, and see you next time.</a:t>
             </a:r>
             <a:endParaRPr lang="en-US" dirty="0"/>
           </a:p>
@@ -4163,7 +4160,7 @@
           <a:p>
             <a:r>
               <a:rPr lang="en-US" dirty="0"/>
-              <a:t>For your homework: Ask someone who has lived in Yaoundé, Douala or Bertoua to describe the trees and plants around the town. Write three things he or she says. We shall correct it at the beginning of our next lesson.</a:t>
+              <a:t>Let us play the bilingual game. I say a word in English, and you give me the French word. Then we do the reverse.</a:t>
             </a:r>
             <a:endParaRPr lang="en-US" dirty="0"/>
           </a:p>
@@ -4251,7 +4248,7 @@
           <a:p>
             <a:r>
               <a:rPr lang="en-US" dirty="0"/>
-              <a:t>Our next lesson will be on Lesson 1 (Part 2): The Equatorial Region: Characteristics (Soils and Vegetation). Thank you for your attention, and see you next time.</a:t>
+              <a:t>I record this information in the official logbook of the class after the lesson.</a:t>
             </a:r>
             <a:endParaRPr lang="en-US" dirty="0"/>
           </a:p>
@@ -4339,7 +4336,7 @@
           <a:p>
             <a:r>
               <a:rPr lang="en-US" dirty="0"/>
-              <a:t>Let us play the bilingual game. I say a word in English, and you give me the French word. Then we do the reverse.</a:t>
+              <a:t>I complete the second page of the logbook: the matter taught, the evaluation, the homework and the attendance.</a:t>
             </a:r>
             <a:endParaRPr lang="en-US" dirty="0"/>
           </a:p>
@@ -4515,7 +4512,7 @@
           <a:p>
             <a:r>
               <a:rPr lang="en-US" dirty="0"/>
-              <a:t>I record this information in the official logbook of the class after the lesson.</a:t>
+              <a:t>This slide is for me, the teacher: it gives the timing of the lesson and what to do if the projector is not available.</a:t>
             </a:r>
             <a:endParaRPr lang="en-US" dirty="0"/>
           </a:p>
@@ -4603,7 +4600,7 @@
           <a:p>
             <a:r>
               <a:rPr lang="en-US" dirty="0"/>
-              <a:t>I complete the second page of the logbook: the matter taught, the evaluation, the homework and the attendance.</a:t>
+              <a:t>These are the references and picture credits used to prepare this lesson.</a:t>
             </a:r>
             <a:endParaRPr lang="en-US" dirty="0"/>
           </a:p>
@@ -4627,270 +4624,6 @@
             <a:fld id="{F7021451-1387-4CA6-816F-3879F97B5CBC}" type="slidenum">
               <a:rPr lang="en-US"/>
               <a:t>51</a:t>
-            </a:fld>
-            <a:endParaRPr lang="en-US"/>
-          </a:p>
-        </p:txBody>
-      </p:sp>
-    </p:spTree>
-    <p:extLst>
-      <p:ext uri="{BB962C8B-B14F-4D97-AF65-F5344CB8AC3E}">
-        <p14:creationId xmlns:p14="http://schemas.microsoft.com/office/powerpoint/2010/main" val="1024086991"/>
-      </p:ext>
-    </p:extLst>
-  </p:cSld>
-  <p:clrMapOvr>
-    <a:masterClrMapping/>
-  </p:clrMapOvr>
-</p:notes>
-</file>
-
-<file path=ppt/notesSlides/notesSlide52.xml><?xml version="1.0" encoding="utf-8"?>
-<p:notes xmlns:a="http://schemas.openxmlformats.org/drawingml/2006/main" xmlns:r="http://schemas.openxmlformats.org/officeDocument/2006/relationships" xmlns:p="http://schemas.openxmlformats.org/presentationml/2006/main">
-  <p:cSld>
-    <p:spTree>
-      <p:nvGrpSpPr>
-        <p:cNvPr id="1" name=""/>
-        <p:cNvGrpSpPr/>
-        <p:nvPr/>
-      </p:nvGrpSpPr>
-      <p:grpSpPr>
-        <a:xfrm>
-          <a:off x="0" y="0"/>
-          <a:ext cx="0" cy="0"/>
-          <a:chOff x="0" y="0"/>
-          <a:chExt cx="0" cy="0"/>
-        </a:xfrm>
-      </p:grpSpPr>
-      <p:sp>
-        <p:nvSpPr>
-          <p:cNvPr id="2" name="Slide Image Placeholder 1"/>
-          <p:cNvSpPr>
-            <a:spLocks noGrp="1" noRot="1" noChangeAspect="1"/>
-          </p:cNvSpPr>
-          <p:nvPr>
-            <p:ph type="sldImg"/>
-          </p:nvPr>
-        </p:nvSpPr>
-        <p:spPr/>
-      </p:sp>
-      <p:sp>
-        <p:nvSpPr>
-          <p:cNvPr id="3" name="Notes Placeholder 2"/>
-          <p:cNvSpPr>
-            <a:spLocks noGrp="1"/>
-          </p:cNvSpPr>
-          <p:nvPr>
-            <p:ph type="body" idx="1"/>
-          </p:nvPr>
-        </p:nvSpPr>
-        <p:spPr/>
-        <p:txBody>
-          <a:bodyPr/>
-          <a:lstStyle/>
-          <a:p>
-            <a:r>
-              <a:rPr lang="en-US" dirty="0"/>
-              <a:t>Take your time to copy this part; we will continue together.</a:t>
-            </a:r>
-            <a:endParaRPr lang="en-US" dirty="0"/>
-          </a:p>
-        </p:txBody>
-      </p:sp>
-      <p:sp>
-        <p:nvSpPr>
-          <p:cNvPr id="4" name="Slide Number Placeholder 3"/>
-          <p:cNvSpPr>
-            <a:spLocks noGrp="1"/>
-          </p:cNvSpPr>
-          <p:nvPr>
-            <p:ph type="sldNum" sz="quarter" idx="10"/>
-          </p:nvPr>
-        </p:nvSpPr>
-        <p:spPr/>
-        <p:txBody>
-          <a:bodyPr/>
-          <a:lstStyle/>
-          <a:p>
-            <a:fld id="{F7021451-1387-4CA6-816F-3879F97B5CBC}" type="slidenum">
-              <a:rPr lang="en-US"/>
-              <a:t>52</a:t>
-            </a:fld>
-            <a:endParaRPr lang="en-US"/>
-          </a:p>
-        </p:txBody>
-      </p:sp>
-    </p:spTree>
-    <p:extLst>
-      <p:ext uri="{BB962C8B-B14F-4D97-AF65-F5344CB8AC3E}">
-        <p14:creationId xmlns:p14="http://schemas.microsoft.com/office/powerpoint/2010/main" val="1024086991"/>
-      </p:ext>
-    </p:extLst>
-  </p:cSld>
-  <p:clrMapOvr>
-    <a:masterClrMapping/>
-  </p:clrMapOvr>
-</p:notes>
-</file>
-
-<file path=ppt/notesSlides/notesSlide53.xml><?xml version="1.0" encoding="utf-8"?>
-<p:notes xmlns:a="http://schemas.openxmlformats.org/drawingml/2006/main" xmlns:r="http://schemas.openxmlformats.org/officeDocument/2006/relationships" xmlns:p="http://schemas.openxmlformats.org/presentationml/2006/main">
-  <p:cSld>
-    <p:spTree>
-      <p:nvGrpSpPr>
-        <p:cNvPr id="1" name=""/>
-        <p:cNvGrpSpPr/>
-        <p:nvPr/>
-      </p:nvGrpSpPr>
-      <p:grpSpPr>
-        <a:xfrm>
-          <a:off x="0" y="0"/>
-          <a:ext cx="0" cy="0"/>
-          <a:chOff x="0" y="0"/>
-          <a:chExt cx="0" cy="0"/>
-        </a:xfrm>
-      </p:grpSpPr>
-      <p:sp>
-        <p:nvSpPr>
-          <p:cNvPr id="2" name="Slide Image Placeholder 1"/>
-          <p:cNvSpPr>
-            <a:spLocks noGrp="1" noRot="1" noChangeAspect="1"/>
-          </p:cNvSpPr>
-          <p:nvPr>
-            <p:ph type="sldImg"/>
-          </p:nvPr>
-        </p:nvSpPr>
-        <p:spPr/>
-      </p:sp>
-      <p:sp>
-        <p:nvSpPr>
-          <p:cNvPr id="3" name="Notes Placeholder 2"/>
-          <p:cNvSpPr>
-            <a:spLocks noGrp="1"/>
-          </p:cNvSpPr>
-          <p:nvPr>
-            <p:ph type="body" idx="1"/>
-          </p:nvPr>
-        </p:nvSpPr>
-        <p:spPr/>
-        <p:txBody>
-          <a:bodyPr/>
-          <a:lstStyle/>
-          <a:p>
-            <a:r>
-              <a:rPr lang="en-US" dirty="0"/>
-              <a:t>This slide is for me, the teacher: it gives the timing of the lesson and what to do if the projector is not available.</a:t>
-            </a:r>
-            <a:endParaRPr lang="en-US" dirty="0"/>
-          </a:p>
-        </p:txBody>
-      </p:sp>
-      <p:sp>
-        <p:nvSpPr>
-          <p:cNvPr id="4" name="Slide Number Placeholder 3"/>
-          <p:cNvSpPr>
-            <a:spLocks noGrp="1"/>
-          </p:cNvSpPr>
-          <p:nvPr>
-            <p:ph type="sldNum" sz="quarter" idx="10"/>
-          </p:nvPr>
-        </p:nvSpPr>
-        <p:spPr/>
-        <p:txBody>
-          <a:bodyPr/>
-          <a:lstStyle/>
-          <a:p>
-            <a:fld id="{F7021451-1387-4CA6-816F-3879F97B5CBC}" type="slidenum">
-              <a:rPr lang="en-US"/>
-              <a:t>53</a:t>
-            </a:fld>
-            <a:endParaRPr lang="en-US"/>
-          </a:p>
-        </p:txBody>
-      </p:sp>
-    </p:spTree>
-    <p:extLst>
-      <p:ext uri="{BB962C8B-B14F-4D97-AF65-F5344CB8AC3E}">
-        <p14:creationId xmlns:p14="http://schemas.microsoft.com/office/powerpoint/2010/main" val="1024086991"/>
-      </p:ext>
-    </p:extLst>
-  </p:cSld>
-  <p:clrMapOvr>
-    <a:masterClrMapping/>
-  </p:clrMapOvr>
-</p:notes>
-</file>
-
-<file path=ppt/notesSlides/notesSlide54.xml><?xml version="1.0" encoding="utf-8"?>
-<p:notes xmlns:a="http://schemas.openxmlformats.org/drawingml/2006/main" xmlns:r="http://schemas.openxmlformats.org/officeDocument/2006/relationships" xmlns:p="http://schemas.openxmlformats.org/presentationml/2006/main">
-  <p:cSld>
-    <p:spTree>
-      <p:nvGrpSpPr>
-        <p:cNvPr id="1" name=""/>
-        <p:cNvGrpSpPr/>
-        <p:nvPr/>
-      </p:nvGrpSpPr>
-      <p:grpSpPr>
-        <a:xfrm>
-          <a:off x="0" y="0"/>
-          <a:ext cx="0" cy="0"/>
-          <a:chOff x="0" y="0"/>
-          <a:chExt cx="0" cy="0"/>
-        </a:xfrm>
-      </p:grpSpPr>
-      <p:sp>
-        <p:nvSpPr>
-          <p:cNvPr id="2" name="Slide Image Placeholder 1"/>
-          <p:cNvSpPr>
-            <a:spLocks noGrp="1" noRot="1" noChangeAspect="1"/>
-          </p:cNvSpPr>
-          <p:nvPr>
-            <p:ph type="sldImg"/>
-          </p:nvPr>
-        </p:nvSpPr>
-        <p:spPr/>
-      </p:sp>
-      <p:sp>
-        <p:nvSpPr>
-          <p:cNvPr id="3" name="Notes Placeholder 2"/>
-          <p:cNvSpPr>
-            <a:spLocks noGrp="1"/>
-          </p:cNvSpPr>
-          <p:nvPr>
-            <p:ph type="body" idx="1"/>
-          </p:nvPr>
-        </p:nvSpPr>
-        <p:spPr/>
-        <p:txBody>
-          <a:bodyPr/>
-          <a:lstStyle/>
-          <a:p>
-            <a:r>
-              <a:rPr lang="en-US" dirty="0"/>
-              <a:t>These are the references and picture credits used to prepare this lesson.</a:t>
-            </a:r>
-            <a:endParaRPr lang="en-US" dirty="0"/>
-          </a:p>
-        </p:txBody>
-      </p:sp>
-      <p:sp>
-        <p:nvSpPr>
-          <p:cNvPr id="4" name="Slide Number Placeholder 3"/>
-          <p:cNvSpPr>
-            <a:spLocks noGrp="1"/>
-          </p:cNvSpPr>
-          <p:nvPr>
-            <p:ph type="sldNum" sz="quarter" idx="10"/>
-          </p:nvPr>
-        </p:nvSpPr>
-        <p:spPr/>
-        <p:txBody>
-          <a:bodyPr/>
-          <a:lstStyle/>
-          <a:p>
-            <a:fld id="{F7021451-1387-4CA6-816F-3879F97B5CBC}" type="slidenum">
-              <a:rPr lang="en-US"/>
-              <a:t>54</a:t>
             </a:fld>
             <a:endParaRPr lang="en-US"/>
           </a:p>
@@ -5131,7 +4864,7 @@
           <a:p>
             <a:r>
               <a:rPr lang="en-US" dirty="0"/>
-              <a:t>Listen carefully to this situation from real life. Nadia lives in Garoua. Her cousin in Yaoundé writes to her: "Here it rains in almost every month, the air is hot and wet, and our clothes take a long time to dry." Nadia is surprised, because in Garoua there is no rain for about six months. Think about it, because I am going to ask you some questions.</a:t>
+              <a:t>Listen carefully to this situation from real life. Nadia lives in Garoua. Her cousin in Yaoundé writes: "Here it rains in almost every month, and our clothes take a long time to dry." In Garoua, there is no rain for about six months. Nadia asks: "Why is the weather of Yaoundé so different from ours?" Think about it, because I am going to ask you some questions.</a:t>
             </a:r>
             <a:endParaRPr lang="en-US" dirty="0"/>
           </a:p>
@@ -6683,7 +6416,7 @@
                 <a:ea typeface="Times New Roman" pitchFamily="34" charset="-122"/>
                 <a:cs typeface="Times New Roman" pitchFamily="34" charset="-120"/>
               </a:rPr>
-              <a:t>Nadia does not understand why it rains in almost every month in Yaoundé.</a:t>
+              <a:t>Nadia does not know why Yaoundé is wet all year while Garoua has a long dry season.</a:t>
             </a:r>
             <a:endParaRPr lang="en-US" sz="4000" dirty="0"/>
           </a:p>
@@ -7121,7 +6854,7 @@
                 <a:ea typeface="Times New Roman" pitchFamily="34" charset="-122"/>
                 <a:cs typeface="Times New Roman" pitchFamily="34" charset="-120"/>
               </a:rPr>
-              <a:t>It is hot and wet, with rain in almost every month.</a:t>
+              <a:t>It rains in almost every month and the air is wet.</a:t>
             </a:r>
             <a:endParaRPr lang="en-US" sz="4000" dirty="0"/>
           </a:p>
@@ -7340,7 +7073,7 @@
                 <a:ea typeface="Times New Roman" pitchFamily="34" charset="-122"/>
                 <a:cs typeface="Times New Roman" pitchFamily="34" charset="-120"/>
               </a:rPr>
-              <a:t>Why is Yaoundé wetter than Garoua?</a:t>
+              <a:t>In which natural region is Yaoundé?</a:t>
             </a:r>
             <a:endParaRPr lang="en-US" sz="4000" dirty="0"/>
           </a:p>
@@ -7559,7 +7292,7 @@
                 <a:ea typeface="Times New Roman" pitchFamily="34" charset="-122"/>
                 <a:cs typeface="Times New Roman" pitchFamily="34" charset="-120"/>
               </a:rPr>
-              <a:t>Yaoundé is closer to the Equator, in the Equatorial region.</a:t>
+              <a:t>In the Equatorial region.</a:t>
             </a:r>
             <a:endParaRPr lang="en-US" sz="4000" dirty="0"/>
           </a:p>
@@ -8109,7 +7842,7 @@
                 <a:ea typeface="Calibri" pitchFamily="34" charset="-122"/>
                 <a:cs typeface="Calibri" pitchFamily="34" charset="-120"/>
               </a:rPr>
-              <a:t>1. MEANING AND LOCATION</a:t>
+              <a:t>1. LOCATION</a:t>
             </a:r>
             <a:endParaRPr lang="en-US" sz="1400" dirty="0"/>
           </a:p>
@@ -8211,7 +7944,7 @@
                 <a:ea typeface="Times New Roman" pitchFamily="34" charset="-122"/>
                 <a:cs typeface="Times New Roman" pitchFamily="34" charset="-120"/>
               </a:rPr>
-              <a:t>A thick forest near the Equator.</a:t>
+              <a:t>A thick forest.</a:t>
             </a:r>
             <a:endParaRPr lang="en-US" sz="1800" dirty="0"/>
           </a:p>
@@ -8323,7 +8056,7 @@
                 <a:ea typeface="Calibri" pitchFamily="34" charset="-122"/>
                 <a:cs typeface="Calibri" pitchFamily="34" charset="-120"/>
               </a:rPr>
-              <a:t>1. MEANING AND LOCATION</a:t>
+              <a:t>1. LOCATION</a:t>
             </a:r>
             <a:endParaRPr lang="en-US" sz="1400" dirty="0"/>
           </a:p>
@@ -8430,7 +8163,7 @@
                 <a:ea typeface="Times New Roman" pitchFamily="34" charset="-122"/>
                 <a:cs typeface="Times New Roman" pitchFamily="34" charset="-120"/>
               </a:rPr>
-              <a:t>Describe the vegetation in the picture. In which natural region do we find it?</a:t>
+              <a:t>In which natural region do we find this thick, green forest?</a:t>
             </a:r>
             <a:endParaRPr lang="en-US" sz="4000" dirty="0"/>
           </a:p>
@@ -8542,7 +8275,7 @@
                 <a:ea typeface="Calibri" pitchFamily="34" charset="-122"/>
                 <a:cs typeface="Calibri" pitchFamily="34" charset="-120"/>
               </a:rPr>
-              <a:t>1. MEANING AND LOCATION</a:t>
+              <a:t>1. LOCATION</a:t>
             </a:r>
             <a:endParaRPr lang="en-US" sz="1400" dirty="0"/>
           </a:p>
@@ -8649,7 +8382,7 @@
                 <a:ea typeface="Times New Roman" pitchFamily="34" charset="-122"/>
                 <a:cs typeface="Times New Roman" pitchFamily="34" charset="-120"/>
               </a:rPr>
-              <a:t>It is a thick, green forest with tall trees close together. We find it in the Equatorial region.</a:t>
+              <a:t>In the Equatorial region.</a:t>
             </a:r>
             <a:endParaRPr lang="en-US" sz="4000" dirty="0"/>
           </a:p>
@@ -9356,7 +9089,7 @@
                 <a:ea typeface="Calibri" pitchFamily="34" charset="-122"/>
                 <a:cs typeface="Calibri" pitchFamily="34" charset="-120"/>
               </a:rPr>
-              <a:t>1. MEANING AND LOCATION</a:t>
+              <a:t>1. LOCATION</a:t>
             </a:r>
             <a:endParaRPr lang="en-US" sz="1400" dirty="0"/>
           </a:p>
@@ -9570,7 +9303,7 @@
                 <a:ea typeface="Calibri" pitchFamily="34" charset="-122"/>
                 <a:cs typeface="Calibri" pitchFamily="34" charset="-120"/>
               </a:rPr>
-              <a:t>1. MEANING AND LOCATION</a:t>
+              <a:t>1. LOCATION</a:t>
             </a:r>
             <a:endParaRPr lang="en-US" sz="1400" dirty="0"/>
           </a:p>
@@ -9677,7 +9410,7 @@
                 <a:ea typeface="Times New Roman" pitchFamily="34" charset="-122"/>
                 <a:cs typeface="Times New Roman" pitchFamily="34" charset="-120"/>
               </a:rPr>
-              <a:t>Between which latitudes is the Equatorial region found? Name three areas.</a:t>
+              <a:t>Between which latitudes is the Equatorial region found?</a:t>
             </a:r>
             <a:endParaRPr lang="en-US" sz="4000" dirty="0"/>
           </a:p>
@@ -9789,7 +9522,7 @@
                 <a:ea typeface="Calibri" pitchFamily="34" charset="-122"/>
                 <a:cs typeface="Calibri" pitchFamily="34" charset="-120"/>
               </a:rPr>
-              <a:t>1. MEANING AND LOCATION</a:t>
+              <a:t>1. LOCATION</a:t>
             </a:r>
             <a:endParaRPr lang="en-US" sz="1400" dirty="0"/>
           </a:p>
@@ -9896,7 +9629,7 @@
                 <a:ea typeface="Times New Roman" pitchFamily="34" charset="-122"/>
                 <a:cs typeface="Times New Roman" pitchFamily="34" charset="-120"/>
               </a:rPr>
-              <a:t>Between about 5° N and 5° S of the Equator: the Amazon Basin, the Congo Basin and South-East Asia.</a:t>
+              <a:t>Between about 5° N and 5° S of the Equator.</a:t>
             </a:r>
             <a:endParaRPr lang="en-US" sz="4000" dirty="0"/>
           </a:p>
@@ -10110,7 +9843,7 @@
                 <a:ea typeface="Times New Roman" pitchFamily="34" charset="-122"/>
                 <a:cs typeface="Times New Roman" pitchFamily="34" charset="-120"/>
               </a:rPr>
-              <a:t>The climate of Yaoundé: rain (blue bars) and temperature (red line).</a:t>
+              <a:t>The climate of Yaoundé.</a:t>
             </a:r>
             <a:endParaRPr lang="en-US" sz="1800" dirty="0"/>
           </a:p>
@@ -10329,7 +10062,7 @@
                 <a:ea typeface="Times New Roman" pitchFamily="34" charset="-122"/>
                 <a:cs typeface="Times New Roman" pitchFamily="34" charset="-120"/>
               </a:rPr>
-              <a:t>Look at the red line. Is Yaoundé hot or cold? Does the temperature change much during the year?</a:t>
+              <a:t>Look at the red line. Is Yaoundé hot or cold during the year?</a:t>
             </a:r>
             <a:endParaRPr lang="en-US" sz="4000" dirty="0"/>
           </a:p>
@@ -10548,7 +10281,7 @@
                 <a:ea typeface="Times New Roman" pitchFamily="34" charset="-122"/>
                 <a:cs typeface="Times New Roman" pitchFamily="34" charset="-120"/>
               </a:rPr>
-              <a:t>It is hot all year, about 23 °C to 25 °C. The temperature changes very little, so the annual range is small.</a:t>
+              <a:t>It is hot all year, about 23 °C to 25 °C.</a:t>
             </a:r>
             <a:endParaRPr lang="en-US" sz="4000" dirty="0"/>
           </a:p>
@@ -10762,7 +10495,7 @@
                 <a:ea typeface="Times New Roman" pitchFamily="34" charset="-122"/>
                 <a:cs typeface="Times New Roman" pitchFamily="34" charset="-120"/>
               </a:rPr>
-              <a:t>The climate of Yaoundé: two rainy seasons.</a:t>
+              <a:t>The climate of Yaoundé.</a:t>
             </a:r>
             <a:endParaRPr lang="en-US" sz="1800" dirty="0"/>
           </a:p>
@@ -10981,7 +10714,7 @@
                 <a:ea typeface="Times New Roman" pitchFamily="34" charset="-122"/>
                 <a:cs typeface="Times New Roman" pitchFamily="34" charset="-120"/>
               </a:rPr>
-              <a:t>Look at the blue bars. Does it rain in every month? How many rainy seasons are there?</a:t>
+              <a:t>Look at the blue bars. Does it rain in every month?</a:t>
             </a:r>
             <a:endParaRPr lang="en-US" sz="4000" dirty="0"/>
           </a:p>
@@ -11200,7 +10933,7 @@
                 <a:ea typeface="Times New Roman" pitchFamily="34" charset="-122"/>
                 <a:cs typeface="Times New Roman" pitchFamily="34" charset="-120"/>
               </a:rPr>
-              <a:t>It rains in almost every month. There are two rainy seasons, with the heaviest rains in May and in October.</a:t>
+              <a:t>Yes, it rains in almost every month.</a:t>
             </a:r>
             <a:endParaRPr lang="en-US" sz="4000" dirty="0"/>
           </a:p>
@@ -11414,7 +11147,7 @@
                 <a:ea typeface="Times New Roman" pitchFamily="34" charset="-122"/>
                 <a:cs typeface="Times New Roman" pitchFamily="34" charset="-120"/>
               </a:rPr>
-              <a:t>A big storm cloud in the afternoon.</a:t>
+              <a:t>A storm.</a:t>
             </a:r>
             <a:endParaRPr lang="en-US" sz="1800" dirty="0"/>
           </a:p>
@@ -12642,7 +12375,7 @@
                 <a:ea typeface="Times New Roman" pitchFamily="34" charset="-122"/>
                 <a:cs typeface="Times New Roman" pitchFamily="34" charset="-120"/>
               </a:rPr>
-              <a:t>In the Equatorial region, heavy rain often falls in the afternoon. Why?</a:t>
+              <a:t>At what time of the day does heavy rain often fall in the Equatorial region?</a:t>
             </a:r>
             <a:endParaRPr lang="en-US" sz="4000" dirty="0"/>
           </a:p>
@@ -12861,7 +12594,7 @@
                 <a:ea typeface="Times New Roman" pitchFamily="34" charset="-122"/>
                 <a:cs typeface="Times New Roman" pitchFamily="34" charset="-120"/>
               </a:rPr>
-              <a:t>The hot sun heats the wet air in the morning. The air rises, cools and forms big clouds that give heavy rain with thunder in the afternoon: this is convectional rain.</a:t>
+              <a:t>In the afternoon, after the sun has heated the air.</a:t>
             </a:r>
             <a:endParaRPr lang="en-US" sz="4000" dirty="0"/>
           </a:p>
@@ -13072,7 +12805,7 @@
               <a:buNone/>
             </a:pPr>
             <a:r>
-              <a:rPr lang="en-US" sz="4000" b="1" dirty="0">
+              <a:rPr lang="en-US" sz="3200" b="1" dirty="0">
                 <a:solidFill>
                   <a:srgbClr val="111111"/>
                 </a:solidFill>
@@ -13082,7 +12815,7 @@
               </a:rPr>
               <a:t>Topic: Man in His Environment</a:t>
             </a:r>
-            <a:endParaRPr lang="en-US" sz="4000" dirty="0"/>
+            <a:endParaRPr lang="en-US" sz="3200" dirty="0"/>
           </a:p>
           <a:p>
             <a:pPr algn="l" indent="0" marL="0">
@@ -13092,7 +12825,7 @@
               <a:buNone/>
             </a:pPr>
             <a:r>
-              <a:rPr lang="en-US" sz="4000" b="1" dirty="0">
+              <a:rPr lang="en-US" sz="3200" b="1" dirty="0">
                 <a:solidFill>
                   <a:srgbClr val="111111"/>
                 </a:solidFill>
@@ -13102,7 +12835,7 @@
               </a:rPr>
               <a:t>Sub-topic: Natural Regions</a:t>
             </a:r>
-            <a:endParaRPr lang="en-US" sz="4000" dirty="0"/>
+            <a:endParaRPr lang="en-US" sz="3200" dirty="0"/>
           </a:p>
           <a:p>
             <a:pPr algn="l" indent="0" marL="0">
@@ -13112,7 +12845,7 @@
               <a:buNone/>
             </a:pPr>
             <a:r>
-              <a:rPr lang="en-US" sz="4000" b="1" dirty="0">
+              <a:rPr lang="en-US" sz="3200" b="1" dirty="0">
                 <a:solidFill>
                   <a:srgbClr val="990011"/>
                 </a:solidFill>
@@ -13122,7 +12855,7 @@
               </a:rPr>
               <a:t>Lesson 1 (Part 1): The Equatorial Region: Location and Characteristics (Climate)</a:t>
             </a:r>
-            <a:endParaRPr lang="en-US" sz="4000" dirty="0"/>
+            <a:endParaRPr lang="en-US" sz="3200" dirty="0"/>
           </a:p>
         </p:txBody>
       </p:sp>
@@ -13255,7 +12988,7 @@
         <p:spPr>
           <a:xfrm>
             <a:off x="0" y="658368"/>
-            <a:ext cx="5120640" cy="5833872"/>
+            <a:ext cx="2468880" cy="5833872"/>
           </a:xfrm>
           <a:prstGeom prst="rect">
             <a:avLst/>
@@ -13270,8 +13003,8 @@
         </p:nvSpPr>
         <p:spPr>
           <a:xfrm>
-            <a:off x="5349240" y="1005840"/>
-            <a:ext cx="6522415" cy="731520"/>
+            <a:off x="2697480" y="1005840"/>
+            <a:ext cx="9174175" cy="731520"/>
           </a:xfrm>
           <a:prstGeom prst="rect">
             <a:avLst/>
@@ -13297,7 +13030,7 @@
                 <a:ea typeface="Times New Roman" pitchFamily="34" charset="-122"/>
                 <a:cs typeface="Times New Roman" pitchFamily="34" charset="-120"/>
               </a:rPr>
-              <a:t>1. Meaning and Location</a:t>
+              <a:t>DEFINITIONS</a:t>
             </a:r>
             <a:endParaRPr lang="en-US" sz="3600" dirty="0"/>
           </a:p>
@@ -13311,47 +13044,8 @@
         </p:nvSpPr>
         <p:spPr>
           <a:xfrm>
-            <a:off x="5349240" y="1737360"/>
-            <a:ext cx="6522415" cy="457200"/>
-          </a:xfrm>
-          <a:prstGeom prst="rect">
-            <a:avLst/>
-          </a:prstGeom>
-          <a:noFill/>
-          <a:ln/>
-        </p:spPr>
-        <p:txBody>
-          <a:bodyPr wrap="square" lIns="0" tIns="0" rIns="0" bIns="0" rtlCol="0" anchor="ctr"/>
-          <a:lstStyle/>
-          <a:p>
-            <a:pPr algn="l" indent="0" marL="0">
-              <a:buNone/>
-            </a:pPr>
-            <a:r>
-              <a:rPr lang="en-US" sz="3200" b="1" dirty="0">
-                <a:solidFill>
-                  <a:srgbClr val="990011"/>
-                </a:solidFill>
-                <a:latin typeface="Times New Roman" pitchFamily="34" charset="0"/>
-                <a:ea typeface="Times New Roman" pitchFamily="34" charset="-122"/>
-                <a:cs typeface="Times New Roman" pitchFamily="34" charset="-120"/>
-              </a:rPr>
-              <a:t>A) Meaning</a:t>
-            </a:r>
-            <a:endParaRPr lang="en-US" sz="3200" dirty="0"/>
-          </a:p>
-        </p:txBody>
-      </p:sp>
-      <p:sp>
-        <p:nvSpPr>
-          <p:cNvPr id="6" name="Text 3"/>
-          <p:cNvSpPr/>
-          <p:nvPr/>
-        </p:nvSpPr>
-        <p:spPr>
-          <a:xfrm>
-            <a:off x="5349240" y="2240280"/>
-            <a:ext cx="6522415" cy="4206240"/>
+            <a:off x="2697480" y="1783080"/>
+            <a:ext cx="9174175" cy="4663440"/>
           </a:xfrm>
           <a:prstGeom prst="rect">
             <a:avLst/>
@@ -13378,16 +13072,17 @@
                 <a:ea typeface="Times New Roman" pitchFamily="34" charset="-122"/>
                 <a:cs typeface="Times New Roman" pitchFamily="34" charset="-120"/>
               </a:rPr>
-              <a:t>The Equatorial region is defined as follows:</a:t>
+              <a:t>The key terms of this lesson are defined as follows:</a:t>
             </a:r>
             <a:endParaRPr lang="en-US" sz="4000" dirty="0"/>
           </a:p>
           <a:p>
-            <a:pPr algn="l" indent="0" marL="0">
+            <a:pPr algn="l" marL="342900" indent="-342900">
               <a:spcAft>
                 <a:spcPts val="800"/>
               </a:spcAft>
-              <a:buNone/>
+              <a:buSzPct val="100000"/>
+              <a:buChar char="•"/>
             </a:pPr>
             <a:r>
               <a:rPr lang="en-US" sz="4000" b="1" dirty="0">
@@ -13400,11 +13095,12 @@
               </a:rPr>
               <a:t>Equatorial region: </a:t>
             </a:r>
-            <a:pPr algn="l" indent="0" marL="0">
+            <a:pPr algn="l" marL="342900" indent="-342900">
               <a:spcAft>
                 <a:spcPts val="800"/>
               </a:spcAft>
-              <a:buNone/>
+              <a:buSzPct val="100000"/>
+              <a:buChar char="•"/>
             </a:pPr>
             <a:r>
               <a:rPr lang="en-US" sz="4000" dirty="0">
@@ -13415,7 +13111,46 @@
                 <a:ea typeface="Times New Roman" pitchFamily="34" charset="-122"/>
                 <a:cs typeface="Times New Roman" pitchFamily="34" charset="-120"/>
               </a:rPr>
-              <a:t>It is the hot and wet region found on both sides of the Equator, covered by a thick forest.</a:t>
+              <a:t>It is the hot and wet region on both sides of the Equator.</a:t>
+            </a:r>
+            <a:endParaRPr lang="en-US" sz="4000" dirty="0"/>
+          </a:p>
+          <a:p>
+            <a:pPr algn="l" marL="342900" indent="-342900">
+              <a:spcAft>
+                <a:spcPts val="800"/>
+              </a:spcAft>
+              <a:buSzPct val="100000"/>
+              <a:buChar char="•"/>
+            </a:pPr>
+            <a:r>
+              <a:rPr lang="en-US" sz="4000" b="1" dirty="0">
+                <a:solidFill>
+                  <a:srgbClr val="111111"/>
+                </a:solidFill>
+                <a:latin typeface="Times New Roman" pitchFamily="34" charset="0"/>
+                <a:ea typeface="Times New Roman" pitchFamily="34" charset="-122"/>
+                <a:cs typeface="Times New Roman" pitchFamily="34" charset="-120"/>
+              </a:rPr>
+              <a:t>Climate: </a:t>
+            </a:r>
+            <a:pPr algn="l" marL="342900" indent="-342900">
+              <a:spcAft>
+                <a:spcPts val="800"/>
+              </a:spcAft>
+              <a:buSzPct val="100000"/>
+              <a:buChar char="•"/>
+            </a:pPr>
+            <a:r>
+              <a:rPr lang="en-US" sz="4000" dirty="0">
+                <a:solidFill>
+                  <a:srgbClr val="111111"/>
+                </a:solidFill>
+                <a:latin typeface="Times New Roman" pitchFamily="34" charset="0"/>
+                <a:ea typeface="Times New Roman" pitchFamily="34" charset="-122"/>
+                <a:cs typeface="Times New Roman" pitchFamily="34" charset="-120"/>
+              </a:rPr>
+              <a:t>It is the average weather of a place over many years.</a:t>
             </a:r>
             <a:endParaRPr lang="en-US" sz="4000" dirty="0"/>
           </a:p>
@@ -13533,9 +13268,131 @@
           </a:p>
         </p:txBody>
       </p:sp>
+      <p:sp>
+        <p:nvSpPr>
+          <p:cNvPr id="3" name="Text 1"/>
+          <p:cNvSpPr/>
+          <p:nvPr/>
+        </p:nvSpPr>
+        <p:spPr>
+          <a:xfrm>
+            <a:off x="365760" y="1005840"/>
+            <a:ext cx="11460175" cy="731520"/>
+          </a:xfrm>
+          <a:prstGeom prst="rect">
+            <a:avLst/>
+          </a:prstGeom>
+          <a:noFill/>
+          <a:ln/>
+        </p:spPr>
+        <p:txBody>
+          <a:bodyPr wrap="square" lIns="0" tIns="0" rIns="0" bIns="0" rtlCol="0" anchor="ctr">
+            <a:normAutofit/>
+          </a:bodyPr>
+          <a:lstStyle/>
+          <a:p>
+            <a:pPr algn="ctr" indent="0" marL="0">
+              <a:buNone/>
+            </a:pPr>
+            <a:r>
+              <a:rPr lang="en-US" sz="3600" b="1" dirty="0">
+                <a:solidFill>
+                  <a:srgbClr val="990011"/>
+                </a:solidFill>
+                <a:latin typeface="Times New Roman" pitchFamily="34" charset="0"/>
+                <a:ea typeface="Times New Roman" pitchFamily="34" charset="-122"/>
+                <a:cs typeface="Times New Roman" pitchFamily="34" charset="-120"/>
+              </a:rPr>
+              <a:t>1. Location</a:t>
+            </a:r>
+            <a:endParaRPr lang="en-US" sz="3600" dirty="0"/>
+          </a:p>
+        </p:txBody>
+      </p:sp>
+      <p:sp>
+        <p:nvSpPr>
+          <p:cNvPr id="4" name="Text 2"/>
+          <p:cNvSpPr/>
+          <p:nvPr/>
+        </p:nvSpPr>
+        <p:spPr>
+          <a:xfrm>
+            <a:off x="365760" y="1783080"/>
+            <a:ext cx="4846320" cy="4617720"/>
+          </a:xfrm>
+          <a:prstGeom prst="rect">
+            <a:avLst/>
+          </a:prstGeom>
+          <a:noFill/>
+          <a:ln/>
+        </p:spPr>
+        <p:txBody>
+          <a:bodyPr wrap="square" lIns="0" tIns="0" rIns="0" bIns="0" rtlCol="0" anchor="t"/>
+          <a:lstStyle/>
+          <a:p>
+            <a:pPr algn="l" indent="0" marL="0">
+              <a:spcAft>
+                <a:spcPts val="800"/>
+              </a:spcAft>
+              <a:buNone/>
+            </a:pPr>
+            <a:r>
+              <a:rPr lang="en-US" sz="3600" i="1" dirty="0">
+                <a:solidFill>
+                  <a:srgbClr val="111111"/>
+                </a:solidFill>
+                <a:latin typeface="Times New Roman" pitchFamily="34" charset="0"/>
+                <a:ea typeface="Times New Roman" pitchFamily="34" charset="-122"/>
+                <a:cs typeface="Times New Roman" pitchFamily="34" charset="-120"/>
+              </a:rPr>
+              <a:t>The Equatorial region lies between 5° N and 5° S:</a:t>
+            </a:r>
+            <a:endParaRPr lang="en-US" sz="3600" dirty="0"/>
+          </a:p>
+          <a:p>
+            <a:pPr algn="l" marL="342900" indent="-342900">
+              <a:spcAft>
+                <a:spcPts val="800"/>
+              </a:spcAft>
+              <a:buSzPct val="100000"/>
+              <a:buChar char="•"/>
+            </a:pPr>
+            <a:r>
+              <a:rPr lang="en-US" sz="3600" b="1" dirty="0">
+                <a:solidFill>
+                  <a:srgbClr val="111111"/>
+                </a:solidFill>
+                <a:latin typeface="Times New Roman" pitchFamily="34" charset="0"/>
+                <a:ea typeface="Times New Roman" pitchFamily="34" charset="-122"/>
+                <a:cs typeface="Times New Roman" pitchFamily="34" charset="-120"/>
+              </a:rPr>
+              <a:t>Africa: </a:t>
+            </a:r>
+            <a:pPr algn="l" marL="342900" indent="-342900">
+              <a:spcAft>
+                <a:spcPts val="800"/>
+              </a:spcAft>
+              <a:buSzPct val="100000"/>
+              <a:buChar char="•"/>
+            </a:pPr>
+            <a:r>
+              <a:rPr lang="en-US" sz="3600" dirty="0">
+                <a:solidFill>
+                  <a:srgbClr val="111111"/>
+                </a:solidFill>
+                <a:latin typeface="Times New Roman" pitchFamily="34" charset="0"/>
+                <a:ea typeface="Times New Roman" pitchFamily="34" charset="-122"/>
+                <a:cs typeface="Times New Roman" pitchFamily="34" charset="-120"/>
+              </a:rPr>
+              <a:t>The Congo Basin, southern Cameroon and Gabon.</a:t>
+            </a:r>
+            <a:endParaRPr lang="en-US" sz="3600" dirty="0"/>
+          </a:p>
+        </p:txBody>
+      </p:sp>
       <p:pic>
         <p:nvPicPr>
-          <p:cNvPr id="3" name="Image 0" descr="/home/claude/f4/img/minesec_sheet.png">    </p:cNvPr>
+          <p:cNvPr id="5" name="Image 0" descr="/home/claude/f4/img/v2/equatorial_world_big.png">    </p:cNvPr>
           <p:cNvPicPr>
             <a:picLocks noChangeAspect="1"/>
           </p:cNvPicPr>
@@ -13549,8 +13406,8 @@
         </p:blipFill>
         <p:spPr>
           <a:xfrm>
-            <a:off x="0" y="658368"/>
-            <a:ext cx="1463040" cy="5833872"/>
+            <a:off x="5349240" y="3111771"/>
+            <a:ext cx="6659575" cy="1612866"/>
           </a:xfrm>
           <a:prstGeom prst="rect">
             <a:avLst/>
@@ -13559,14 +13416,14 @@
       </p:pic>
       <p:sp>
         <p:nvSpPr>
-          <p:cNvPr id="4" name="Text 1"/>
+          <p:cNvPr id="6" name="Text 3"/>
           <p:cNvSpPr/>
           <p:nvPr/>
         </p:nvSpPr>
         <p:spPr>
           <a:xfrm>
-            <a:off x="1691640" y="1005840"/>
-            <a:ext cx="10180015" cy="731520"/>
+            <a:off x="5349240" y="6089904"/>
+            <a:ext cx="6659575" cy="347472"/>
           </a:xfrm>
           <a:prstGeom prst="rect">
             <a:avLst/>
@@ -13575,181 +13432,24 @@
           <a:ln/>
         </p:spPr>
         <p:txBody>
-          <a:bodyPr wrap="square" lIns="0" tIns="0" rIns="0" bIns="0" rtlCol="0" anchor="ctr">
-            <a:normAutofit/>
-          </a:bodyPr>
+          <a:bodyPr wrap="square" lIns="0" tIns="0" rIns="0" bIns="0" rtlCol="0" anchor="ctr"/>
           <a:lstStyle/>
           <a:p>
             <a:pPr algn="ctr" indent="0" marL="0">
               <a:buNone/>
             </a:pPr>
             <a:r>
-              <a:rPr lang="en-US" sz="3600" b="1" dirty="0">
-                <a:solidFill>
-                  <a:srgbClr val="990011"/>
+              <a:rPr lang="en-US" sz="1600" i="1" dirty="0">
+                <a:solidFill>
+                  <a:srgbClr val="555555"/>
                 </a:solidFill>
                 <a:latin typeface="Times New Roman" pitchFamily="34" charset="0"/>
                 <a:ea typeface="Times New Roman" pitchFamily="34" charset="-122"/>
                 <a:cs typeface="Times New Roman" pitchFamily="34" charset="-120"/>
               </a:rPr>
-              <a:t>1. Meaning and Location</a:t>
-            </a:r>
-            <a:endParaRPr lang="en-US" sz="3600" dirty="0"/>
-          </a:p>
-        </p:txBody>
-      </p:sp>
-      <p:sp>
-        <p:nvSpPr>
-          <p:cNvPr id="5" name="Text 2"/>
-          <p:cNvSpPr/>
-          <p:nvPr/>
-        </p:nvSpPr>
-        <p:spPr>
-          <a:xfrm>
-            <a:off x="1691640" y="1737360"/>
-            <a:ext cx="10180015" cy="457200"/>
-          </a:xfrm>
-          <a:prstGeom prst="rect">
-            <a:avLst/>
-          </a:prstGeom>
-          <a:noFill/>
-          <a:ln/>
-        </p:spPr>
-        <p:txBody>
-          <a:bodyPr wrap="square" lIns="0" tIns="0" rIns="0" bIns="0" rtlCol="0" anchor="ctr"/>
-          <a:lstStyle/>
-          <a:p>
-            <a:pPr algn="l" indent="0" marL="0">
-              <a:buNone/>
-            </a:pPr>
-            <a:r>
-              <a:rPr lang="en-US" sz="3200" b="1" dirty="0">
-                <a:solidFill>
-                  <a:srgbClr val="990011"/>
-                </a:solidFill>
-                <a:latin typeface="Times New Roman" pitchFamily="34" charset="0"/>
-                <a:ea typeface="Times New Roman" pitchFamily="34" charset="-122"/>
-                <a:cs typeface="Times New Roman" pitchFamily="34" charset="-120"/>
-              </a:rPr>
-              <a:t>B) Location</a:t>
-            </a:r>
-            <a:endParaRPr lang="en-US" sz="3200" dirty="0"/>
-          </a:p>
-        </p:txBody>
-      </p:sp>
-      <p:sp>
-        <p:nvSpPr>
-          <p:cNvPr id="6" name="Text 3"/>
-          <p:cNvSpPr/>
-          <p:nvPr/>
-        </p:nvSpPr>
-        <p:spPr>
-          <a:xfrm>
-            <a:off x="1691640" y="2240280"/>
-            <a:ext cx="10180015" cy="4206240"/>
-          </a:xfrm>
-          <a:prstGeom prst="rect">
-            <a:avLst/>
-          </a:prstGeom>
-          <a:noFill/>
-          <a:ln/>
-        </p:spPr>
-        <p:txBody>
-          <a:bodyPr wrap="square" lIns="0" tIns="0" rIns="0" bIns="0" rtlCol="0" anchor="t"/>
-          <a:lstStyle/>
-          <a:p>
-            <a:pPr algn="l" indent="0" marL="0">
-              <a:spcAft>
-                <a:spcPts val="800"/>
-              </a:spcAft>
-              <a:buNone/>
-            </a:pPr>
-            <a:r>
-              <a:rPr lang="en-US" sz="4000" i="1" dirty="0">
-                <a:solidFill>
-                  <a:srgbClr val="111111"/>
-                </a:solidFill>
-                <a:latin typeface="Times New Roman" pitchFamily="34" charset="0"/>
-                <a:ea typeface="Times New Roman" pitchFamily="34" charset="-122"/>
-                <a:cs typeface="Times New Roman" pitchFamily="34" charset="-120"/>
-              </a:rPr>
-              <a:t>The Equatorial region lies between about 5° N and 5° S of the Equator:</a:t>
-            </a:r>
-            <a:endParaRPr lang="en-US" sz="4000" dirty="0"/>
-          </a:p>
-          <a:p>
-            <a:pPr algn="l" indent="0" marL="0">
-              <a:spcAft>
-                <a:spcPts val="800"/>
-              </a:spcAft>
-              <a:buNone/>
-            </a:pPr>
-            <a:r>
-              <a:rPr lang="en-US" sz="4000" b="1" dirty="0">
-                <a:solidFill>
-                  <a:srgbClr val="111111"/>
-                </a:solidFill>
-                <a:latin typeface="Times New Roman" pitchFamily="34" charset="0"/>
-                <a:ea typeface="Times New Roman" pitchFamily="34" charset="-122"/>
-                <a:cs typeface="Times New Roman" pitchFamily="34" charset="-120"/>
-              </a:rPr>
-              <a:t>Africa: </a:t>
-            </a:r>
-            <a:pPr algn="l" indent="0" marL="0">
-              <a:spcAft>
-                <a:spcPts val="800"/>
-              </a:spcAft>
-              <a:buNone/>
-            </a:pPr>
-            <a:r>
-              <a:rPr lang="en-US" sz="4000" dirty="0">
-                <a:solidFill>
-                  <a:srgbClr val="111111"/>
-                </a:solidFill>
-                <a:latin typeface="Times New Roman" pitchFamily="34" charset="0"/>
-                <a:ea typeface="Times New Roman" pitchFamily="34" charset="-122"/>
-                <a:cs typeface="Times New Roman" pitchFamily="34" charset="-120"/>
-              </a:rPr>
-              <a:t>It covers the Congo Basin, southern Cameroon, Gabon and the Guinea coast.</a:t>
-            </a:r>
-            <a:endParaRPr lang="en-US" sz="4000" dirty="0"/>
-          </a:p>
-          <a:p>
-            <a:pPr algn="l" indent="0" marL="0">
-              <a:spcAft>
-                <a:spcPts val="800"/>
-              </a:spcAft>
-              <a:buNone/>
-            </a:pPr>
-            <a:r>
-              <a:rPr lang="en-US" sz="4000" b="1" dirty="0">
-                <a:solidFill>
-                  <a:srgbClr val="111111"/>
-                </a:solidFill>
-                <a:latin typeface="Times New Roman" pitchFamily="34" charset="0"/>
-                <a:ea typeface="Times New Roman" pitchFamily="34" charset="-122"/>
-                <a:cs typeface="Times New Roman" pitchFamily="34" charset="-120"/>
-              </a:rPr>
-              <a:t>South America: </a:t>
-            </a:r>
-            <a:pPr algn="l" indent="0" marL="0">
-              <a:spcAft>
-                <a:spcPts val="800"/>
-              </a:spcAft>
-              <a:buNone/>
-            </a:pPr>
-            <a:r>
-              <a:rPr lang="en-US" sz="4000" dirty="0">
-                <a:solidFill>
-                  <a:srgbClr val="111111"/>
-                </a:solidFill>
-                <a:latin typeface="Times New Roman" pitchFamily="34" charset="0"/>
-                <a:ea typeface="Times New Roman" pitchFamily="34" charset="-122"/>
-                <a:cs typeface="Times New Roman" pitchFamily="34" charset="-120"/>
-              </a:rPr>
-              <a:t>It covers the Amazon Basin in Brazil.</a:t>
-            </a:r>
-            <a:endParaRPr lang="en-US" sz="4000" dirty="0"/>
+              <a:t>Illustration: the Equatorial regions of the world</a:t>
+            </a:r>
+            <a:endParaRPr lang="en-US" sz="1600" dirty="0"/>
           </a:p>
         </p:txBody>
       </p:sp>
@@ -13924,7 +13624,7 @@
                 <a:ea typeface="Times New Roman" pitchFamily="34" charset="-122"/>
                 <a:cs typeface="Times New Roman" pitchFamily="34" charset="-120"/>
               </a:rPr>
-              <a:t>1. Meaning and Location</a:t>
+              <a:t>1. Location</a:t>
             </a:r>
             <a:endParaRPr lang="en-US" sz="3600" dirty="0"/>
           </a:p>
@@ -13938,8 +13638,8 @@
         </p:nvSpPr>
         <p:spPr>
           <a:xfrm>
-            <a:off x="5349240" y="1737360"/>
-            <a:ext cx="6522415" cy="457200"/>
+            <a:off x="5349240" y="1783080"/>
+            <a:ext cx="6522415" cy="4663440"/>
           </a:xfrm>
           <a:prstGeom prst="rect">
             <a:avLst/>
@@ -13948,53 +13648,54 @@
           <a:ln/>
         </p:spPr>
         <p:txBody>
-          <a:bodyPr wrap="square" lIns="0" tIns="0" rIns="0" bIns="0" rtlCol="0" anchor="ctr"/>
-          <a:lstStyle/>
-          <a:p>
-            <a:pPr algn="l" indent="0" marL="0">
-              <a:buNone/>
+          <a:bodyPr wrap="square" lIns="0" tIns="0" rIns="0" bIns="0" rtlCol="0" anchor="t"/>
+          <a:lstStyle/>
+          <a:p>
+            <a:pPr algn="l" marL="342900" indent="-342900">
+              <a:spcAft>
+                <a:spcPts val="800"/>
+              </a:spcAft>
+              <a:buSzPct val="100000"/>
+              <a:buChar char="•"/>
             </a:pPr>
             <a:r>
-              <a:rPr lang="en-US" sz="3200" b="1" dirty="0">
-                <a:solidFill>
-                  <a:srgbClr val="990011"/>
+              <a:rPr lang="en-US" sz="4000" b="1" dirty="0">
+                <a:solidFill>
+                  <a:srgbClr val="111111"/>
                 </a:solidFill>
                 <a:latin typeface="Times New Roman" pitchFamily="34" charset="0"/>
                 <a:ea typeface="Times New Roman" pitchFamily="34" charset="-122"/>
                 <a:cs typeface="Times New Roman" pitchFamily="34" charset="-120"/>
               </a:rPr>
-              <a:t>B) Location (continued)</a:t>
-            </a:r>
-            <a:endParaRPr lang="en-US" sz="3200" dirty="0"/>
-          </a:p>
-        </p:txBody>
-      </p:sp>
-      <p:sp>
-        <p:nvSpPr>
-          <p:cNvPr id="6" name="Text 3"/>
-          <p:cNvSpPr/>
-          <p:nvPr/>
-        </p:nvSpPr>
-        <p:spPr>
-          <a:xfrm>
-            <a:off x="5349240" y="2240280"/>
-            <a:ext cx="6522415" cy="4206240"/>
-          </a:xfrm>
-          <a:prstGeom prst="rect">
-            <a:avLst/>
-          </a:prstGeom>
-          <a:noFill/>
-          <a:ln/>
-        </p:spPr>
-        <p:txBody>
-          <a:bodyPr wrap="square" lIns="0" tIns="0" rIns="0" bIns="0" rtlCol="0" anchor="t"/>
-          <a:lstStyle/>
-          <a:p>
-            <a:pPr algn="l" indent="0" marL="0">
+              <a:t>South America: </a:t>
+            </a:r>
+            <a:pPr algn="l" marL="342900" indent="-342900">
               <a:spcAft>
                 <a:spcPts val="800"/>
               </a:spcAft>
-              <a:buNone/>
+              <a:buSzPct val="100000"/>
+              <a:buChar char="•"/>
+            </a:pPr>
+            <a:r>
+              <a:rPr lang="en-US" sz="4000" dirty="0">
+                <a:solidFill>
+                  <a:srgbClr val="111111"/>
+                </a:solidFill>
+                <a:latin typeface="Times New Roman" pitchFamily="34" charset="0"/>
+                <a:ea typeface="Times New Roman" pitchFamily="34" charset="-122"/>
+                <a:cs typeface="Times New Roman" pitchFamily="34" charset="-120"/>
+              </a:rPr>
+              <a:t>The Amazon Basin in Brazil.</a:t>
+            </a:r>
+            <a:endParaRPr lang="en-US" sz="4000" dirty="0"/>
+          </a:p>
+          <a:p>
+            <a:pPr algn="l" marL="342900" indent="-342900">
+              <a:spcAft>
+                <a:spcPts val="800"/>
+              </a:spcAft>
+              <a:buSzPct val="100000"/>
+              <a:buChar char="•"/>
             </a:pPr>
             <a:r>
               <a:rPr lang="en-US" sz="4000" b="1" dirty="0">
@@ -14007,11 +13708,12 @@
               </a:rPr>
               <a:t>Asia: </a:t>
             </a:r>
-            <a:pPr algn="l" indent="0" marL="0">
+            <a:pPr algn="l" marL="342900" indent="-342900">
               <a:spcAft>
                 <a:spcPts val="800"/>
               </a:spcAft>
-              <a:buNone/>
+              <a:buSzPct val="100000"/>
+              <a:buChar char="•"/>
             </a:pPr>
             <a:r>
               <a:rPr lang="en-US" sz="4000" dirty="0">
@@ -14022,7 +13724,7 @@
                 <a:ea typeface="Times New Roman" pitchFamily="34" charset="-122"/>
                 <a:cs typeface="Times New Roman" pitchFamily="34" charset="-120"/>
               </a:rPr>
-              <a:t>It covers Malaysia, Indonesia and the Philippines in South-East Asia.</a:t>
+              <a:t>Malaysia and Indonesia.</a:t>
             </a:r>
             <a:endParaRPr lang="en-US" sz="4000" dirty="0"/>
           </a:p>
@@ -14148,8 +13850,8 @@
         </p:nvSpPr>
         <p:spPr>
           <a:xfrm>
-            <a:off x="457200" y="1005840"/>
-            <a:ext cx="11277295" cy="731520"/>
+            <a:off x="365760" y="1005840"/>
+            <a:ext cx="11460175" cy="731520"/>
           </a:xfrm>
           <a:prstGeom prst="rect">
             <a:avLst/>
@@ -14158,7 +13860,9 @@
           <a:ln/>
         </p:spPr>
         <p:txBody>
-          <a:bodyPr wrap="square" lIns="0" tIns="0" rIns="0" bIns="0" rtlCol="0" anchor="ctr"/>
+          <a:bodyPr wrap="square" lIns="0" tIns="0" rIns="0" bIns="0" rtlCol="0" anchor="ctr">
+            <a:normAutofit/>
+          </a:bodyPr>
           <a:lstStyle/>
           <a:p>
             <a:pPr algn="ctr" indent="0" marL="0">
@@ -14173,7 +13877,88 @@
                 <a:ea typeface="Times New Roman" pitchFamily="34" charset="-122"/>
                 <a:cs typeface="Times New Roman" pitchFamily="34" charset="-120"/>
               </a:rPr>
-              <a:t>1. Meaning and Location</a:t>
+              <a:t>2. Characteristics of the Climate</a:t>
+            </a:r>
+            <a:endParaRPr lang="en-US" sz="3600" dirty="0"/>
+          </a:p>
+        </p:txBody>
+      </p:sp>
+      <p:sp>
+        <p:nvSpPr>
+          <p:cNvPr id="4" name="Text 2"/>
+          <p:cNvSpPr/>
+          <p:nvPr/>
+        </p:nvSpPr>
+        <p:spPr>
+          <a:xfrm>
+            <a:off x="365760" y="1783080"/>
+            <a:ext cx="4846320" cy="4617720"/>
+          </a:xfrm>
+          <a:prstGeom prst="rect">
+            <a:avLst/>
+          </a:prstGeom>
+          <a:noFill/>
+          <a:ln/>
+        </p:spPr>
+        <p:txBody>
+          <a:bodyPr wrap="square" lIns="0" tIns="0" rIns="0" bIns="0" rtlCol="0" anchor="t"/>
+          <a:lstStyle/>
+          <a:p>
+            <a:pPr algn="l" indent="0" marL="0">
+              <a:spcAft>
+                <a:spcPts val="800"/>
+              </a:spcAft>
+              <a:buNone/>
+            </a:pPr>
+            <a:r>
+              <a:rPr lang="en-US" sz="3600" i="1" dirty="0">
+                <a:solidFill>
+                  <a:srgbClr val="111111"/>
+                </a:solidFill>
+                <a:latin typeface="Times New Roman" pitchFamily="34" charset="0"/>
+                <a:ea typeface="Times New Roman" pitchFamily="34" charset="-122"/>
+                <a:cs typeface="Times New Roman" pitchFamily="34" charset="-120"/>
+              </a:rPr>
+              <a:t>The equatorial climate has the following characteristics:</a:t>
+            </a:r>
+            <a:endParaRPr lang="en-US" sz="3600" dirty="0"/>
+          </a:p>
+          <a:p>
+            <a:pPr algn="l" marL="342900" indent="-342900">
+              <a:spcAft>
+                <a:spcPts val="800"/>
+              </a:spcAft>
+              <a:buSzPct val="100000"/>
+              <a:buChar char="•"/>
+            </a:pPr>
+            <a:r>
+              <a:rPr lang="en-US" sz="3600" b="1" dirty="0">
+                <a:solidFill>
+                  <a:srgbClr val="111111"/>
+                </a:solidFill>
+                <a:latin typeface="Times New Roman" pitchFamily="34" charset="0"/>
+                <a:ea typeface="Times New Roman" pitchFamily="34" charset="-122"/>
+                <a:cs typeface="Times New Roman" pitchFamily="34" charset="-120"/>
+              </a:rPr>
+              <a:t>Hot all year: </a:t>
+            </a:r>
+            <a:pPr algn="l" marL="342900" indent="-342900">
+              <a:spcAft>
+                <a:spcPts val="800"/>
+              </a:spcAft>
+              <a:buSzPct val="100000"/>
+              <a:buChar char="•"/>
+            </a:pPr>
+            <a:r>
+              <a:rPr lang="en-US" sz="3600" dirty="0">
+                <a:solidFill>
+                  <a:srgbClr val="111111"/>
+                </a:solidFill>
+                <a:latin typeface="Times New Roman" pitchFamily="34" charset="0"/>
+                <a:ea typeface="Times New Roman" pitchFamily="34" charset="-122"/>
+                <a:cs typeface="Times New Roman" pitchFamily="34" charset="-120"/>
+              </a:rPr>
+              <a:t>The temperature is about 23 to 25 °C in every month.</a:t>
             </a:r>
             <a:endParaRPr lang="en-US" sz="3600" dirty="0"/>
           </a:p>
@@ -14181,7 +13966,7 @@
       </p:sp>
       <p:pic>
         <p:nvPicPr>
-          <p:cNvPr id="4" name="Image 0" descr="/home/claude/f4/img/v2/equatorial_world_big.png">    </p:cNvPr>
+          <p:cNvPr id="5" name="Image 0" descr="/home/claude/f4/img/v2/yaounde_climate_big.png">    </p:cNvPr>
           <p:cNvPicPr>
             <a:picLocks noChangeAspect="1"/>
           </p:cNvPicPr>
@@ -14195,8 +13980,8 @@
         </p:blipFill>
         <p:spPr>
           <a:xfrm>
-            <a:off x="274320" y="2508303"/>
-            <a:ext cx="11643055" cy="2819802"/>
+            <a:off x="5349240" y="2461422"/>
+            <a:ext cx="6659575" cy="2913564"/>
           </a:xfrm>
           <a:prstGeom prst="rect">
             <a:avLst/>
@@ -14205,14 +13990,14 @@
       </p:pic>
       <p:sp>
         <p:nvSpPr>
-          <p:cNvPr id="5" name="Text 2"/>
+          <p:cNvPr id="6" name="Text 3"/>
           <p:cNvSpPr/>
           <p:nvPr/>
         </p:nvSpPr>
         <p:spPr>
           <a:xfrm>
-            <a:off x="457200" y="6089904"/>
-            <a:ext cx="11277295" cy="347472"/>
+            <a:off x="5349240" y="6089904"/>
+            <a:ext cx="6659575" cy="347472"/>
           </a:xfrm>
           <a:prstGeom prst="rect">
             <a:avLst/>
@@ -14228,7 +14013,7 @@
               <a:buNone/>
             </a:pPr>
             <a:r>
-              <a:rPr lang="en-US" sz="1800" i="1" dirty="0">
+              <a:rPr lang="en-US" sz="1600" i="1" dirty="0">
                 <a:solidFill>
                   <a:srgbClr val="555555"/>
                 </a:solidFill>
@@ -14236,9 +14021,9 @@
                 <a:ea typeface="Times New Roman" pitchFamily="34" charset="-122"/>
                 <a:cs typeface="Times New Roman" pitchFamily="34" charset="-120"/>
               </a:rPr>
-              <a:t>Illustration: the Equatorial regions of the world</a:t>
-            </a:r>
-            <a:endParaRPr lang="en-US" sz="1800" dirty="0"/>
+              <a:t>Illustration: the climate of Yaoundé</a:t>
+            </a:r>
+            <a:endParaRPr lang="en-US" sz="1600" dirty="0"/>
           </a:p>
         </p:txBody>
       </p:sp>
@@ -14371,7 +14156,7 @@
         <p:spPr>
           <a:xfrm>
             <a:off x="0" y="658368"/>
-            <a:ext cx="2468880" cy="5833872"/>
+            <a:ext cx="1463040" cy="5833872"/>
           </a:xfrm>
           <a:prstGeom prst="rect">
             <a:avLst/>
@@ -14386,8 +14171,8 @@
         </p:nvSpPr>
         <p:spPr>
           <a:xfrm>
-            <a:off x="2697480" y="1005840"/>
-            <a:ext cx="9174175" cy="731520"/>
+            <a:off x="1691640" y="1005840"/>
+            <a:ext cx="10180015" cy="731520"/>
           </a:xfrm>
           <a:prstGeom prst="rect">
             <a:avLst/>
@@ -14427,8 +14212,8 @@
         </p:nvSpPr>
         <p:spPr>
           <a:xfrm>
-            <a:off x="2697480" y="1783080"/>
-            <a:ext cx="9174175" cy="4663440"/>
+            <a:off x="1691640" y="1783080"/>
+            <a:ext cx="10180015" cy="4663440"/>
           </a:xfrm>
           <a:prstGeom prst="rect">
             <a:avLst/>
@@ -14440,14 +14225,15 @@
           <a:bodyPr wrap="square" lIns="0" tIns="0" rIns="0" bIns="0" rtlCol="0" anchor="t"/>
           <a:lstStyle/>
           <a:p>
-            <a:pPr algn="l" indent="0" marL="0">
+            <a:pPr algn="l" marL="342900" indent="-342900">
               <a:spcAft>
                 <a:spcPts val="800"/>
               </a:spcAft>
-              <a:buNone/>
+              <a:buSzPct val="100000"/>
+              <a:buChar char="•"/>
             </a:pPr>
             <a:r>
-              <a:rPr lang="en-US" sz="4000" i="1" dirty="0">
+              <a:rPr lang="en-US" sz="4000" b="1" dirty="0">
                 <a:solidFill>
                   <a:srgbClr val="111111"/>
                 </a:solidFill>
@@ -14455,19 +14241,17 @@
                 <a:ea typeface="Times New Roman" pitchFamily="34" charset="-122"/>
                 <a:cs typeface="Times New Roman" pitchFamily="34" charset="-120"/>
               </a:rPr>
-              <a:t>The equatorial climate has the following characteristics:</a:t>
-            </a:r>
-            <a:endParaRPr lang="en-US" sz="4000" dirty="0"/>
-          </a:p>
-          <a:p>
-            <a:pPr algn="l" indent="0" marL="0">
+              <a:t>Small annual range: </a:t>
+            </a:r>
+            <a:pPr algn="l" marL="342900" indent="-342900">
               <a:spcAft>
                 <a:spcPts val="800"/>
               </a:spcAft>
-              <a:buNone/>
+              <a:buSzPct val="100000"/>
+              <a:buChar char="•"/>
             </a:pPr>
             <a:r>
-              <a:rPr lang="en-US" sz="4000" b="1" dirty="0">
+              <a:rPr lang="en-US" sz="4000" dirty="0">
                 <a:solidFill>
                   <a:srgbClr val="111111"/>
                 </a:solidFill>
@@ -14475,16 +14259,20 @@
                 <a:ea typeface="Times New Roman" pitchFamily="34" charset="-122"/>
                 <a:cs typeface="Times New Roman" pitchFamily="34" charset="-120"/>
               </a:rPr>
-              <a:t>Temperature: </a:t>
-            </a:r>
-            <a:pPr algn="l" indent="0" marL="0">
+              <a:t>The temperature changes by less than 3 °C during the year.</a:t>
+            </a:r>
+            <a:endParaRPr lang="en-US" sz="4000" dirty="0"/>
+          </a:p>
+          <a:p>
+            <a:pPr algn="l" marL="342900" indent="-342900">
               <a:spcAft>
                 <a:spcPts val="800"/>
               </a:spcAft>
-              <a:buNone/>
+              <a:buSzPct val="100000"/>
+              <a:buChar char="•"/>
             </a:pPr>
             <a:r>
-              <a:rPr lang="en-US" sz="4000" dirty="0">
+              <a:rPr lang="en-US" sz="4000" b="1" dirty="0">
                 <a:solidFill>
                   <a:srgbClr val="111111"/>
                 </a:solidFill>
@@ -14492,19 +14280,17 @@
                 <a:ea typeface="Times New Roman" pitchFamily="34" charset="-122"/>
                 <a:cs typeface="Times New Roman" pitchFamily="34" charset="-120"/>
               </a:rPr>
-              <a:t>It is hot all year, with an average of about 25 °C.</a:t>
-            </a:r>
-            <a:endParaRPr lang="en-US" sz="4000" dirty="0"/>
-          </a:p>
-          <a:p>
-            <a:pPr algn="l" indent="0" marL="0">
+              <a:t>Heavy rain: </a:t>
+            </a:r>
+            <a:pPr algn="l" marL="342900" indent="-342900">
               <a:spcAft>
                 <a:spcPts val="800"/>
               </a:spcAft>
-              <a:buNone/>
+              <a:buSzPct val="100000"/>
+              <a:buChar char="•"/>
             </a:pPr>
             <a:r>
-              <a:rPr lang="en-US" sz="4000" b="1" dirty="0">
+              <a:rPr lang="en-US" sz="4000" dirty="0">
                 <a:solidFill>
                   <a:srgbClr val="111111"/>
                 </a:solidFill>
@@ -14512,16 +14298,20 @@
                 <a:ea typeface="Times New Roman" pitchFamily="34" charset="-122"/>
                 <a:cs typeface="Times New Roman" pitchFamily="34" charset="-120"/>
               </a:rPr>
-              <a:t>Annual range: </a:t>
-            </a:r>
-            <a:pPr algn="l" indent="0" marL="0">
+              <a:t>It rains in almost every month, with 1,500 to 2,500 mm per year.</a:t>
+            </a:r>
+            <a:endParaRPr lang="en-US" sz="4000" dirty="0"/>
+          </a:p>
+          <a:p>
+            <a:pPr algn="l" marL="342900" indent="-342900">
               <a:spcAft>
                 <a:spcPts val="800"/>
               </a:spcAft>
-              <a:buNone/>
+              <a:buSzPct val="100000"/>
+              <a:buChar char="•"/>
             </a:pPr>
             <a:r>
-              <a:rPr lang="en-US" sz="4000" dirty="0">
+              <a:rPr lang="en-US" sz="4000" b="1" dirty="0">
                 <a:solidFill>
                   <a:srgbClr val="111111"/>
                 </a:solidFill>
@@ -14529,7 +14319,25 @@
                 <a:ea typeface="Times New Roman" pitchFamily="34" charset="-122"/>
                 <a:cs typeface="Times New Roman" pitchFamily="34" charset="-120"/>
               </a:rPr>
-              <a:t>The difference between the hottest and the coldest month is very small, less than 3 °C.</a:t>
+              <a:t>Afternoon storms: </a:t>
+            </a:r>
+            <a:pPr algn="l" marL="342900" indent="-342900">
+              <a:spcAft>
+                <a:spcPts val="800"/>
+              </a:spcAft>
+              <a:buSzPct val="100000"/>
+              <a:buChar char="•"/>
+            </a:pPr>
+            <a:r>
+              <a:rPr lang="en-US" sz="4000" dirty="0">
+                <a:solidFill>
+                  <a:srgbClr val="111111"/>
+                </a:solidFill>
+                <a:latin typeface="Times New Roman" pitchFamily="34" charset="0"/>
+                <a:ea typeface="Times New Roman" pitchFamily="34" charset="-122"/>
+                <a:cs typeface="Times New Roman" pitchFamily="34" charset="-120"/>
+              </a:rPr>
+              <a:t>Convectional rain falls in the afternoon with thunder.</a:t>
             </a:r>
             <a:endParaRPr lang="en-US" sz="4000" dirty="0"/>
           </a:p>
@@ -14664,7 +14472,7 @@
         <p:spPr>
           <a:xfrm>
             <a:off x="0" y="658368"/>
-            <a:ext cx="3840480" cy="5833872"/>
+            <a:ext cx="5120640" cy="5833872"/>
           </a:xfrm>
           <a:prstGeom prst="rect">
             <a:avLst/>
@@ -14679,8 +14487,8 @@
         </p:nvSpPr>
         <p:spPr>
           <a:xfrm>
-            <a:off x="4069080" y="1005840"/>
-            <a:ext cx="7802575" cy="731520"/>
+            <a:off x="5349240" y="1005840"/>
+            <a:ext cx="6522415" cy="731520"/>
           </a:xfrm>
           <a:prstGeom prst="rect">
             <a:avLst/>
@@ -14720,8 +14528,8 @@
         </p:nvSpPr>
         <p:spPr>
           <a:xfrm>
-            <a:off x="4069080" y="1783080"/>
-            <a:ext cx="7802575" cy="4663440"/>
+            <a:off x="5349240" y="1783080"/>
+            <a:ext cx="6522415" cy="4663440"/>
           </a:xfrm>
           <a:prstGeom prst="rect">
             <a:avLst/>
@@ -14733,11 +14541,12 @@
           <a:bodyPr wrap="square" lIns="0" tIns="0" rIns="0" bIns="0" rtlCol="0" anchor="t"/>
           <a:lstStyle/>
           <a:p>
-            <a:pPr algn="l" indent="0" marL="0">
+            <a:pPr algn="l" marL="342900" indent="-342900">
               <a:spcAft>
                 <a:spcPts val="800"/>
               </a:spcAft>
-              <a:buNone/>
+              <a:buSzPct val="100000"/>
+              <a:buChar char="•"/>
             </a:pPr>
             <a:r>
               <a:rPr lang="en-US" sz="4000" b="1" dirty="0">
@@ -14748,13 +14557,14 @@
                 <a:ea typeface="Times New Roman" pitchFamily="34" charset="-122"/>
                 <a:cs typeface="Times New Roman" pitchFamily="34" charset="-120"/>
               </a:rPr>
-              <a:t>Rainfall: </a:t>
-            </a:r>
-            <a:pPr algn="l" indent="0" marL="0">
+              <a:t>High humidity: </a:t>
+            </a:r>
+            <a:pPr algn="l" marL="342900" indent="-342900">
               <a:spcAft>
                 <a:spcPts val="800"/>
               </a:spcAft>
-              <a:buNone/>
+              <a:buSzPct val="100000"/>
+              <a:buChar char="•"/>
             </a:pPr>
             <a:r>
               <a:rPr lang="en-US" sz="4000" dirty="0">
@@ -14765,44 +14575,7 @@
                 <a:ea typeface="Times New Roman" pitchFamily="34" charset="-122"/>
                 <a:cs typeface="Times New Roman" pitchFamily="34" charset="-120"/>
               </a:rPr>
-              <a:t>It rains in almost every month, with 1,500 mm to 2,500 mm per year and two rainy peaks.</a:t>
-            </a:r>
-            <a:endParaRPr lang="en-US" sz="4000" dirty="0"/>
-          </a:p>
-          <a:p>
-            <a:pPr algn="l" indent="0" marL="0">
-              <a:spcAft>
-                <a:spcPts val="800"/>
-              </a:spcAft>
-              <a:buNone/>
-            </a:pPr>
-            <a:r>
-              <a:rPr lang="en-US" sz="4000" b="1" dirty="0">
-                <a:solidFill>
-                  <a:srgbClr val="111111"/>
-                </a:solidFill>
-                <a:latin typeface="Times New Roman" pitchFamily="34" charset="0"/>
-                <a:ea typeface="Times New Roman" pitchFamily="34" charset="-122"/>
-                <a:cs typeface="Times New Roman" pitchFamily="34" charset="-120"/>
-              </a:rPr>
-              <a:t>Convectional rain: </a:t>
-            </a:r>
-            <a:pPr algn="l" indent="0" marL="0">
-              <a:spcAft>
-                <a:spcPts val="800"/>
-              </a:spcAft>
-              <a:buNone/>
-            </a:pPr>
-            <a:r>
-              <a:rPr lang="en-US" sz="4000" dirty="0">
-                <a:solidFill>
-                  <a:srgbClr val="111111"/>
-                </a:solidFill>
-                <a:latin typeface="Times New Roman" pitchFamily="34" charset="0"/>
-                <a:ea typeface="Times New Roman" pitchFamily="34" charset="-122"/>
-                <a:cs typeface="Times New Roman" pitchFamily="34" charset="-120"/>
-              </a:rPr>
-              <a:t>Heavy rain with thunder often falls in the afternoon after strong heating by the sun.</a:t>
+              <a:t>The air is always wet.</a:t>
             </a:r>
             <a:endParaRPr lang="en-US" sz="4000" dirty="0"/>
           </a:p>
@@ -14914,7 +14687,7 @@
                 <a:ea typeface="Calibri" pitchFamily="34" charset="-122"/>
                 <a:cs typeface="Calibri" pitchFamily="34" charset="-120"/>
               </a:rPr>
-              <a:t>BOARD SUMMARY</a:t>
+              <a:t>FORMATIVE EVALUATION</a:t>
             </a:r>
             <a:endParaRPr lang="en-US" sz="1400" dirty="0"/>
           </a:p>
@@ -14979,7 +14752,7 @@
                 <a:ea typeface="Times New Roman" pitchFamily="34" charset="-122"/>
                 <a:cs typeface="Times New Roman" pitchFamily="34" charset="-120"/>
               </a:rPr>
-              <a:t>2. Characteristics of the Climate (continued)</a:t>
+              <a:t>Evaluation 1</a:t>
             </a:r>
             <a:endParaRPr lang="en-US" sz="3600" dirty="0"/>
           </a:p>
@@ -15013,7 +14786,7 @@
               <a:buNone/>
             </a:pPr>
             <a:r>
-              <a:rPr lang="en-US" sz="4000" b="1" dirty="0">
+              <a:rPr lang="en-US" sz="4000" dirty="0">
                 <a:solidFill>
                   <a:srgbClr val="111111"/>
                 </a:solidFill>
@@ -15021,24 +14794,7 @@
                 <a:ea typeface="Times New Roman" pitchFamily="34" charset="-122"/>
                 <a:cs typeface="Times New Roman" pitchFamily="34" charset="-120"/>
               </a:rPr>
-              <a:t>Humidity: </a:t>
-            </a:r>
-            <a:pPr algn="l" indent="0" marL="0">
-              <a:spcAft>
-                <a:spcPts val="800"/>
-              </a:spcAft>
-              <a:buNone/>
-            </a:pPr>
-            <a:r>
-              <a:rPr lang="en-US" sz="4000" dirty="0">
-                <a:solidFill>
-                  <a:srgbClr val="111111"/>
-                </a:solidFill>
-                <a:latin typeface="Times New Roman" pitchFamily="34" charset="0"/>
-                <a:ea typeface="Times New Roman" pitchFamily="34" charset="-122"/>
-                <a:cs typeface="Times New Roman" pitchFamily="34" charset="-120"/>
-              </a:rPr>
-              <a:t>The air is always wet, so clothes dry slowly.</a:t>
+              <a:t>Between which latitudes is the Equatorial region found?</a:t>
             </a:r>
             <a:endParaRPr lang="en-US" sz="4000" dirty="0"/>
           </a:p>
@@ -15459,54 +15215,15 @@
                 <a:ea typeface="Calibri" pitchFamily="34" charset="-122"/>
                 <a:cs typeface="Calibri" pitchFamily="34" charset="-120"/>
               </a:rPr>
-              <a:t>BOARD SUMMARY</a:t>
+              <a:t>FORMATIVE EVALUATION</a:t>
             </a:r>
             <a:endParaRPr lang="en-US" sz="1400" dirty="0"/>
-          </a:p>
-        </p:txBody>
-      </p:sp>
-      <p:sp>
-        <p:nvSpPr>
-          <p:cNvPr id="3" name="Text 1"/>
-          <p:cNvSpPr/>
-          <p:nvPr/>
-        </p:nvSpPr>
-        <p:spPr>
-          <a:xfrm>
-            <a:off x="457200" y="1005840"/>
-            <a:ext cx="11277295" cy="731520"/>
-          </a:xfrm>
-          <a:prstGeom prst="rect">
-            <a:avLst/>
-          </a:prstGeom>
-          <a:noFill/>
-          <a:ln/>
-        </p:spPr>
-        <p:txBody>
-          <a:bodyPr wrap="square" lIns="0" tIns="0" rIns="0" bIns="0" rtlCol="0" anchor="ctr"/>
-          <a:lstStyle/>
-          <a:p>
-            <a:pPr algn="ctr" indent="0" marL="0">
-              <a:buNone/>
-            </a:pPr>
-            <a:r>
-              <a:rPr lang="en-US" sz="3600" b="1" dirty="0">
-                <a:solidFill>
-                  <a:srgbClr val="990011"/>
-                </a:solidFill>
-                <a:latin typeface="Times New Roman" pitchFamily="34" charset="0"/>
-                <a:ea typeface="Times New Roman" pitchFamily="34" charset="-122"/>
-                <a:cs typeface="Times New Roman" pitchFamily="34" charset="-120"/>
-              </a:rPr>
-              <a:t>2. Characteristics of the Climate</a:t>
-            </a:r>
-            <a:endParaRPr lang="en-US" sz="3600" dirty="0"/>
           </a:p>
         </p:txBody>
       </p:sp>
       <p:pic>
         <p:nvPicPr>
-          <p:cNvPr id="4" name="Image 0" descr="/home/claude/f4/img/v2/yaounde_climate_big.png">    </p:cNvPr>
+          <p:cNvPr id="3" name="Image 0" descr="/home/claude/f4/img/minesec_sheet.png">    </p:cNvPr>
           <p:cNvPicPr>
             <a:picLocks noChangeAspect="1"/>
           </p:cNvPicPr>
@@ -15520,8 +15237,8 @@
         </p:blipFill>
         <p:spPr>
           <a:xfrm>
-            <a:off x="1215564" y="1783080"/>
-            <a:ext cx="9760567" cy="4270248"/>
+            <a:off x="0" y="658368"/>
+            <a:ext cx="5120640" cy="5833872"/>
           </a:xfrm>
           <a:prstGeom prst="rect">
             <a:avLst/>
@@ -15530,14 +15247,14 @@
       </p:pic>
       <p:sp>
         <p:nvSpPr>
-          <p:cNvPr id="5" name="Text 2"/>
+          <p:cNvPr id="4" name="Text 1"/>
           <p:cNvSpPr/>
           <p:nvPr/>
         </p:nvSpPr>
         <p:spPr>
           <a:xfrm>
-            <a:off x="457200" y="6089904"/>
-            <a:ext cx="11277295" cy="347472"/>
+            <a:off x="5349240" y="1005840"/>
+            <a:ext cx="6522415" cy="731520"/>
           </a:xfrm>
           <a:prstGeom prst="rect">
             <a:avLst/>
@@ -15546,24 +15263,68 @@
           <a:ln/>
         </p:spPr>
         <p:txBody>
-          <a:bodyPr wrap="square" lIns="0" tIns="0" rIns="0" bIns="0" rtlCol="0" anchor="ctr"/>
+          <a:bodyPr wrap="square" lIns="0" tIns="0" rIns="0" bIns="0" rtlCol="0" anchor="ctr">
+            <a:normAutofit/>
+          </a:bodyPr>
           <a:lstStyle/>
           <a:p>
             <a:pPr algn="ctr" indent="0" marL="0">
               <a:buNone/>
             </a:pPr>
             <a:r>
-              <a:rPr lang="en-US" sz="1800" i="1" dirty="0">
-                <a:solidFill>
-                  <a:srgbClr val="555555"/>
+              <a:rPr lang="en-US" sz="3600" b="1" dirty="0">
+                <a:solidFill>
+                  <a:srgbClr val="990011"/>
                 </a:solidFill>
                 <a:latin typeface="Times New Roman" pitchFamily="34" charset="0"/>
                 <a:ea typeface="Times New Roman" pitchFamily="34" charset="-122"/>
                 <a:cs typeface="Times New Roman" pitchFamily="34" charset="-120"/>
               </a:rPr>
-              <a:t>Illustration: the climate of Yaoundé</a:t>
-            </a:r>
-            <a:endParaRPr lang="en-US" sz="1800" dirty="0"/>
+              <a:t>Expected Answer</a:t>
+            </a:r>
+            <a:endParaRPr lang="en-US" sz="3600" dirty="0"/>
+          </a:p>
+        </p:txBody>
+      </p:sp>
+      <p:sp>
+        <p:nvSpPr>
+          <p:cNvPr id="5" name="Text 2"/>
+          <p:cNvSpPr/>
+          <p:nvPr/>
+        </p:nvSpPr>
+        <p:spPr>
+          <a:xfrm>
+            <a:off x="5349240" y="1783080"/>
+            <a:ext cx="6522415" cy="4663440"/>
+          </a:xfrm>
+          <a:prstGeom prst="rect">
+            <a:avLst/>
+          </a:prstGeom>
+          <a:noFill/>
+          <a:ln/>
+        </p:spPr>
+        <p:txBody>
+          <a:bodyPr wrap="square" lIns="0" tIns="0" rIns="0" bIns="0" rtlCol="0" anchor="t"/>
+          <a:lstStyle/>
+          <a:p>
+            <a:pPr algn="l" indent="0" marL="0">
+              <a:spcAft>
+                <a:spcPts val="800"/>
+              </a:spcAft>
+              <a:buNone/>
+            </a:pPr>
+            <a:r>
+              <a:rPr lang="en-US" sz="4000" dirty="0">
+                <a:solidFill>
+                  <a:srgbClr val="111111"/>
+                </a:solidFill>
+                <a:latin typeface="Times New Roman" pitchFamily="34" charset="0"/>
+                <a:ea typeface="Times New Roman" pitchFamily="34" charset="-122"/>
+                <a:cs typeface="Times New Roman" pitchFamily="34" charset="-120"/>
+              </a:rPr>
+              <a:t>Between about 5° N and 5° S of the Equator.</a:t>
+            </a:r>
+            <a:endParaRPr lang="en-US" sz="4000" dirty="0"/>
           </a:p>
         </p:txBody>
       </p:sp>
@@ -15738,7 +15499,7 @@
                 <a:ea typeface="Times New Roman" pitchFamily="34" charset="-122"/>
                 <a:cs typeface="Times New Roman" pitchFamily="34" charset="-120"/>
               </a:rPr>
-              <a:t>Evaluation 1</a:t>
+              <a:t>Evaluation 2</a:t>
             </a:r>
             <a:endParaRPr lang="en-US" sz="3600" dirty="0"/>
           </a:p>
@@ -15780,7 +15541,7 @@
                 <a:ea typeface="Times New Roman" pitchFamily="34" charset="-122"/>
                 <a:cs typeface="Times New Roman" pitchFamily="34" charset="-120"/>
               </a:rPr>
-              <a:t>Between which latitudes is the Equatorial region found?</a:t>
+              <a:t>Give two characteristics of the equatorial climate.</a:t>
             </a:r>
             <a:endParaRPr lang="en-US" sz="4000" dirty="0"/>
           </a:p>
@@ -15999,7 +15760,7 @@
                 <a:ea typeface="Times New Roman" pitchFamily="34" charset="-122"/>
                 <a:cs typeface="Times New Roman" pitchFamily="34" charset="-120"/>
               </a:rPr>
-              <a:t>Between about 5° N and 5° S of the Equator.</a:t>
+              <a:t>It is hot all year (about 25 °C) and it rains in almost every month.</a:t>
             </a:r>
             <a:endParaRPr lang="en-US" sz="4000" dirty="0"/>
           </a:p>
@@ -16111,7 +15872,7 @@
                 <a:ea typeface="Calibri" pitchFamily="34" charset="-122"/>
                 <a:cs typeface="Calibri" pitchFamily="34" charset="-120"/>
               </a:rPr>
-              <a:t>FORMATIVE EVALUATION</a:t>
+              <a:t>REMEDIATION</a:t>
             </a:r>
             <a:endParaRPr lang="en-US" sz="1400" dirty="0"/>
           </a:p>
@@ -16176,7 +15937,7 @@
                 <a:ea typeface="Times New Roman" pitchFamily="34" charset="-122"/>
                 <a:cs typeface="Times New Roman" pitchFamily="34" charset="-120"/>
               </a:rPr>
-              <a:t>Evaluation 2</a:t>
+              <a:t>Remediation</a:t>
             </a:r>
             <a:endParaRPr lang="en-US" sz="3600" dirty="0"/>
           </a:p>
@@ -16210,7 +15971,7 @@
               <a:buNone/>
             </a:pPr>
             <a:r>
-              <a:rPr lang="en-US" sz="4000" dirty="0">
+              <a:rPr lang="en-US" sz="4000" b="1" dirty="0">
                 <a:solidFill>
                   <a:srgbClr val="111111"/>
                 </a:solidFill>
@@ -16218,7 +15979,51 @@
                 <a:ea typeface="Times New Roman" pitchFamily="34" charset="-122"/>
                 <a:cs typeface="Times New Roman" pitchFamily="34" charset="-120"/>
               </a:rPr>
-              <a:t>Give two characteristics of the equatorial climate.</a:t>
+              <a:t>Fill in the blanks:</a:t>
+            </a:r>
+            <a:endParaRPr lang="en-US" sz="4000" dirty="0"/>
+          </a:p>
+          <a:p>
+            <a:pPr algn="l" marL="342900" indent="-342900">
+              <a:spcAft>
+                <a:spcPts val="800"/>
+              </a:spcAft>
+              <a:buSzPct val="100000"/>
+              <a:buFont typeface="+mj-lt"/>
+              <a:buAutoNum type="arabicPeriod" startAt="1"/>
+            </a:pPr>
+            <a:r>
+              <a:rPr lang="en-US" sz="4000" dirty="0">
+                <a:solidFill>
+                  <a:srgbClr val="111111"/>
+                </a:solidFill>
+                <a:latin typeface="Times New Roman" pitchFamily="34" charset="0"/>
+                <a:ea typeface="Times New Roman" pitchFamily="34" charset="-122"/>
+                <a:cs typeface="Times New Roman" pitchFamily="34" charset="-120"/>
+              </a:rPr>
+              <a:t>The Equatorial region is found near the ______.</a:t>
+            </a:r>
+            <a:endParaRPr lang="en-US" sz="4000" dirty="0"/>
+          </a:p>
+          <a:p>
+            <a:pPr algn="l" marL="342900" indent="-342900">
+              <a:spcAft>
+                <a:spcPts val="800"/>
+              </a:spcAft>
+              <a:buSzPct val="100000"/>
+              <a:buFont typeface="+mj-lt"/>
+              <a:buAutoNum type="arabicPeriod" startAt="1"/>
+            </a:pPr>
+            <a:r>
+              <a:rPr lang="en-US" sz="4000" dirty="0">
+                <a:solidFill>
+                  <a:srgbClr val="111111"/>
+                </a:solidFill>
+                <a:latin typeface="Times New Roman" pitchFamily="34" charset="0"/>
+                <a:ea typeface="Times New Roman" pitchFamily="34" charset="-122"/>
+                <a:cs typeface="Times New Roman" pitchFamily="34" charset="-120"/>
+              </a:rPr>
+              <a:t>The rain that falls in the afternoon after strong heating is ______ rain.</a:t>
             </a:r>
             <a:endParaRPr lang="en-US" sz="4000" dirty="0"/>
           </a:p>
@@ -16330,7 +16135,7 @@
                 <a:ea typeface="Calibri" pitchFamily="34" charset="-122"/>
                 <a:cs typeface="Calibri" pitchFamily="34" charset="-120"/>
               </a:rPr>
-              <a:t>FORMATIVE EVALUATION</a:t>
+              <a:t>REMEDIATION</a:t>
             </a:r>
             <a:endParaRPr lang="en-US" sz="1400" dirty="0"/>
           </a:p>
@@ -16395,7 +16200,7 @@
                 <a:ea typeface="Times New Roman" pitchFamily="34" charset="-122"/>
                 <a:cs typeface="Times New Roman" pitchFamily="34" charset="-120"/>
               </a:rPr>
-              <a:t>Expected Answer</a:t>
+              <a:t>Remediation (continued)</a:t>
             </a:r>
             <a:endParaRPr lang="en-US" sz="3600" dirty="0"/>
           </a:p>
@@ -16422,11 +16227,13 @@
           <a:bodyPr wrap="square" lIns="0" tIns="0" rIns="0" bIns="0" rtlCol="0" anchor="t"/>
           <a:lstStyle/>
           <a:p>
-            <a:pPr algn="l" indent="0" marL="0">
+            <a:pPr algn="l" marL="342900" indent="-342900">
               <a:spcAft>
                 <a:spcPts val="800"/>
               </a:spcAft>
-              <a:buNone/>
+              <a:buSzPct val="100000"/>
+              <a:buFont typeface="+mj-lt"/>
+              <a:buAutoNum type="arabicPeriod" startAt="1"/>
             </a:pPr>
             <a:r>
               <a:rPr lang="en-US" sz="4000" dirty="0">
@@ -16437,7 +16244,7 @@
                 <a:ea typeface="Times New Roman" pitchFamily="34" charset="-122"/>
                 <a:cs typeface="Times New Roman" pitchFamily="34" charset="-120"/>
               </a:rPr>
-              <a:t>It is hot all year (about 25 °C) and it rains in almost every month.</a:t>
+              <a:t>The difference between the hottest and the coldest month is the annual ______.</a:t>
             </a:r>
             <a:endParaRPr lang="en-US" sz="4000" dirty="0"/>
           </a:p>
@@ -16549,7 +16356,7 @@
                 <a:ea typeface="Calibri" pitchFamily="34" charset="-122"/>
                 <a:cs typeface="Calibri" pitchFamily="34" charset="-120"/>
               </a:rPr>
-              <a:t>REMEDIATION</a:t>
+              <a:t>HOMEWORK</a:t>
             </a:r>
             <a:endParaRPr lang="en-US" sz="1400" dirty="0"/>
           </a:p>
@@ -16614,7 +16421,7 @@
                 <a:ea typeface="Times New Roman" pitchFamily="34" charset="-122"/>
                 <a:cs typeface="Times New Roman" pitchFamily="34" charset="-120"/>
               </a:rPr>
-              <a:t>Remediation</a:t>
+              <a:t>Homework</a:t>
             </a:r>
             <a:endParaRPr lang="en-US" sz="3600" dirty="0"/>
           </a:p>
@@ -16648,7 +16455,7 @@
               <a:buNone/>
             </a:pPr>
             <a:r>
-              <a:rPr lang="en-US" sz="4000" b="1" dirty="0">
+              <a:rPr lang="en-US" sz="4000" dirty="0">
                 <a:solidFill>
                   <a:srgbClr val="111111"/>
                 </a:solidFill>
@@ -16656,51 +16463,7 @@
                 <a:ea typeface="Times New Roman" pitchFamily="34" charset="-122"/>
                 <a:cs typeface="Times New Roman" pitchFamily="34" charset="-120"/>
               </a:rPr>
-              <a:t>Fill in the blanks:</a:t>
-            </a:r>
-            <a:endParaRPr lang="en-US" sz="4000" dirty="0"/>
-          </a:p>
-          <a:p>
-            <a:pPr algn="l" marL="342900" indent="-342900">
-              <a:spcAft>
-                <a:spcPts val="800"/>
-              </a:spcAft>
-              <a:buSzPct val="100000"/>
-              <a:buFont typeface="+mj-lt"/>
-              <a:buAutoNum type="arabicPeriod" startAt="1"/>
-            </a:pPr>
-            <a:r>
-              <a:rPr lang="en-US" sz="4000" dirty="0">
-                <a:solidFill>
-                  <a:srgbClr val="111111"/>
-                </a:solidFill>
-                <a:latin typeface="Times New Roman" pitchFamily="34" charset="0"/>
-                <a:ea typeface="Times New Roman" pitchFamily="34" charset="-122"/>
-                <a:cs typeface="Times New Roman" pitchFamily="34" charset="-120"/>
-              </a:rPr>
-              <a:t>The Equatorial region is found near the ______.</a:t>
-            </a:r>
-            <a:endParaRPr lang="en-US" sz="4000" dirty="0"/>
-          </a:p>
-          <a:p>
-            <a:pPr algn="l" marL="342900" indent="-342900">
-              <a:spcAft>
-                <a:spcPts val="800"/>
-              </a:spcAft>
-              <a:buSzPct val="100000"/>
-              <a:buFont typeface="+mj-lt"/>
-              <a:buAutoNum type="arabicPeriod" startAt="1"/>
-            </a:pPr>
-            <a:r>
-              <a:rPr lang="en-US" sz="4000" dirty="0">
-                <a:solidFill>
-                  <a:srgbClr val="111111"/>
-                </a:solidFill>
-                <a:latin typeface="Times New Roman" pitchFamily="34" charset="0"/>
-                <a:ea typeface="Times New Roman" pitchFamily="34" charset="-122"/>
-                <a:cs typeface="Times New Roman" pitchFamily="34" charset="-120"/>
-              </a:rPr>
-              <a:t>The rain that falls in the afternoon after strong heating is ______ rain.</a:t>
+              <a:t>Ask someone who has lived in Yaoundé, Douala or Bertoua to describe the trees and plants around the town. Write three things he or she says.</a:t>
             </a:r>
             <a:endParaRPr lang="en-US" sz="4000" dirty="0"/>
           </a:p>
@@ -16812,7 +16575,7 @@
                 <a:ea typeface="Calibri" pitchFamily="34" charset="-122"/>
                 <a:cs typeface="Calibri" pitchFamily="34" charset="-120"/>
               </a:rPr>
-              <a:t>REMEDIATION</a:t>
+              <a:t>NEXT LESSON</a:t>
             </a:r>
             <a:endParaRPr lang="en-US" sz="1400" dirty="0"/>
           </a:p>
@@ -16877,7 +16640,7 @@
                 <a:ea typeface="Times New Roman" pitchFamily="34" charset="-122"/>
                 <a:cs typeface="Times New Roman" pitchFamily="34" charset="-120"/>
               </a:rPr>
-              <a:t>Remediation (continued)</a:t>
+              <a:t>Next Lesson</a:t>
             </a:r>
             <a:endParaRPr lang="en-US" sz="3600" dirty="0"/>
           </a:p>
@@ -16901,19 +16664,17 @@
           <a:ln/>
         </p:spPr>
         <p:txBody>
-          <a:bodyPr wrap="square" lIns="0" tIns="0" rIns="0" bIns="0" rtlCol="0" anchor="t"/>
-          <a:lstStyle/>
-          <a:p>
-            <a:pPr algn="l" marL="342900" indent="-342900">
+          <a:bodyPr wrap="square" lIns="0" tIns="0" rIns="0" bIns="0" rtlCol="0" anchor="ctr"/>
+          <a:lstStyle/>
+          <a:p>
+            <a:pPr algn="ctr" indent="0" marL="0">
               <a:spcAft>
                 <a:spcPts val="800"/>
               </a:spcAft>
-              <a:buSzPct val="100000"/>
-              <a:buFont typeface="+mj-lt"/>
-              <a:buAutoNum type="arabicPeriod" startAt="1"/>
+              <a:buNone/>
             </a:pPr>
             <a:r>
-              <a:rPr lang="en-US" sz="4000" dirty="0">
+              <a:rPr lang="en-US" sz="4000" b="1" dirty="0">
                 <a:solidFill>
                   <a:srgbClr val="111111"/>
                 </a:solidFill>
@@ -16921,7 +16682,27 @@
                 <a:ea typeface="Times New Roman" pitchFamily="34" charset="-122"/>
                 <a:cs typeface="Times New Roman" pitchFamily="34" charset="-120"/>
               </a:rPr>
-              <a:t>The difference between the hottest and the coldest month is the annual ______.</a:t>
+              <a:t>Our next lesson will be on:</a:t>
+            </a:r>
+            <a:endParaRPr lang="en-US" sz="4000" dirty="0"/>
+          </a:p>
+          <a:p>
+            <a:pPr algn="ctr" indent="0" marL="0">
+              <a:spcAft>
+                <a:spcPts val="800"/>
+              </a:spcAft>
+              <a:buNone/>
+            </a:pPr>
+            <a:r>
+              <a:rPr lang="en-US" sz="4000" b="1" dirty="0">
+                <a:solidFill>
+                  <a:srgbClr val="990011"/>
+                </a:solidFill>
+                <a:latin typeface="Times New Roman" pitchFamily="34" charset="0"/>
+                <a:ea typeface="Times New Roman" pitchFamily="34" charset="-122"/>
+                <a:cs typeface="Times New Roman" pitchFamily="34" charset="-120"/>
+              </a:rPr>
+              <a:t>Lesson 1 (Part 2): The Equatorial Region: Characteristics (Soils and Vegetation)</a:t>
             </a:r>
             <a:endParaRPr lang="en-US" sz="4000" dirty="0"/>
           </a:p>
@@ -17033,464 +16814,6 @@
                 <a:ea typeface="Calibri" pitchFamily="34" charset="-122"/>
                 <a:cs typeface="Calibri" pitchFamily="34" charset="-120"/>
               </a:rPr>
-              <a:t>HOMEWORK</a:t>
-            </a:r>
-            <a:endParaRPr lang="en-US" sz="1400" dirty="0"/>
-          </a:p>
-        </p:txBody>
-      </p:sp>
-      <p:pic>
-        <p:nvPicPr>
-          <p:cNvPr id="3" name="Image 0" descr="/home/claude/f4/img/minesec_sheet.png">    </p:cNvPr>
-          <p:cNvPicPr>
-            <a:picLocks noChangeAspect="1"/>
-          </p:cNvPicPr>
-          <p:nvPr/>
-        </p:nvPicPr>
-        <p:blipFill>
-          <a:blip r:embed="rId1"/>
-          <a:stretch>
-            <a:fillRect/>
-          </a:stretch>
-        </p:blipFill>
-        <p:spPr>
-          <a:xfrm>
-            <a:off x="0" y="658368"/>
-            <a:ext cx="5120640" cy="5833872"/>
-          </a:xfrm>
-          <a:prstGeom prst="rect">
-            <a:avLst/>
-          </a:prstGeom>
-        </p:spPr>
-      </p:pic>
-      <p:sp>
-        <p:nvSpPr>
-          <p:cNvPr id="4" name="Text 1"/>
-          <p:cNvSpPr/>
-          <p:nvPr/>
-        </p:nvSpPr>
-        <p:spPr>
-          <a:xfrm>
-            <a:off x="5349240" y="1005840"/>
-            <a:ext cx="6522415" cy="731520"/>
-          </a:xfrm>
-          <a:prstGeom prst="rect">
-            <a:avLst/>
-          </a:prstGeom>
-          <a:noFill/>
-          <a:ln/>
-        </p:spPr>
-        <p:txBody>
-          <a:bodyPr wrap="square" lIns="0" tIns="0" rIns="0" bIns="0" rtlCol="0" anchor="ctr">
-            <a:normAutofit/>
-          </a:bodyPr>
-          <a:lstStyle/>
-          <a:p>
-            <a:pPr algn="ctr" indent="0" marL="0">
-              <a:buNone/>
-            </a:pPr>
-            <a:r>
-              <a:rPr lang="en-US" sz="3600" b="1" dirty="0">
-                <a:solidFill>
-                  <a:srgbClr val="990011"/>
-                </a:solidFill>
-                <a:latin typeface="Times New Roman" pitchFamily="34" charset="0"/>
-                <a:ea typeface="Times New Roman" pitchFamily="34" charset="-122"/>
-                <a:cs typeface="Times New Roman" pitchFamily="34" charset="-120"/>
-              </a:rPr>
-              <a:t>Homework</a:t>
-            </a:r>
-            <a:endParaRPr lang="en-US" sz="3600" dirty="0"/>
-          </a:p>
-        </p:txBody>
-      </p:sp>
-      <p:sp>
-        <p:nvSpPr>
-          <p:cNvPr id="5" name="Text 2"/>
-          <p:cNvSpPr/>
-          <p:nvPr/>
-        </p:nvSpPr>
-        <p:spPr>
-          <a:xfrm>
-            <a:off x="5349240" y="1783080"/>
-            <a:ext cx="6522415" cy="4663440"/>
-          </a:xfrm>
-          <a:prstGeom prst="rect">
-            <a:avLst/>
-          </a:prstGeom>
-          <a:noFill/>
-          <a:ln/>
-        </p:spPr>
-        <p:txBody>
-          <a:bodyPr wrap="square" lIns="0" tIns="0" rIns="0" bIns="0" rtlCol="0" anchor="t"/>
-          <a:lstStyle/>
-          <a:p>
-            <a:pPr algn="l" indent="0" marL="0">
-              <a:spcAft>
-                <a:spcPts val="800"/>
-              </a:spcAft>
-              <a:buNone/>
-            </a:pPr>
-            <a:r>
-              <a:rPr lang="en-US" sz="4000" dirty="0">
-                <a:solidFill>
-                  <a:srgbClr val="111111"/>
-                </a:solidFill>
-                <a:latin typeface="Times New Roman" pitchFamily="34" charset="0"/>
-                <a:ea typeface="Times New Roman" pitchFamily="34" charset="-122"/>
-                <a:cs typeface="Times New Roman" pitchFamily="34" charset="-120"/>
-              </a:rPr>
-              <a:t>Ask someone who has lived in Yaoundé, Douala or Bertoua to describe the trees and plants around the town. Write three things he or she says.</a:t>
-            </a:r>
-            <a:endParaRPr lang="en-US" sz="4000" dirty="0"/>
-          </a:p>
-        </p:txBody>
-      </p:sp>
-      <p:sp>
-        <p:nvSpPr>
-          <p:cNvPr id="25" name="Slide Number Placeholder 0"/>
-          <p:cNvSpPr>
-            <a:spLocks noGrp="1"/>
-          </p:cNvSpPr>
-          <p:nvPr>
-            <p:ph type="sldNum" sz="quarter" idx="4294967295"/>
-          </p:nvPr>
-        </p:nvSpPr>
-        <p:spPr>
-          <a:xfrm>
-            <a:off x="27432" y="91440"/>
-            <a:ext cx="585216" cy="475488"/>
-          </a:xfrm>
-          <a:prstGeom prst="rect">
-            <a:avLst/>
-          </a:prstGeom>
-          <a:extLst>
-            <a:ext uri="{C572A759-6A51-4108-AA02-DFA0A04FC94B}">
-              <ma14:wrappingTextBoxFlag xmlns:ma14="http://schemas.microsoft.com/office/mac/drawingml/2011/main" val="0"/>
-            </a:ext>
-          </a:extLst>
-        </p:spPr>
-        <p:txBody>
-          <a:bodyPr/>
-          <a:lstStyle>
-            <a:lvl1pPr>
-              <a:defRPr sz="2000">
-                <a:solidFill>
-                  <a:srgbClr val="FFFFFF"/>
-                </a:solidFill>
-                <a:latin typeface="Calibri"/>
-                <a:ea typeface="Calibri"/>
-                <a:cs typeface="Calibri"/>
-              </a:defRPr>
-            </a:lvl1pPr>
-          </a:lstStyle>
-          <a:p>
-            <a:pPr algn="ctr"/>
-            <a:fld id="{F7021451-1387-4CA6-816F-3879F97B5CBC}" type="slidenum">
-              <a:rPr b="1" lang="en-US"/>
-              <a:t>47</a:t>
-            </a:fld>
-            <a:endParaRPr lang="en-US"/>
-          </a:p>
-        </p:txBody>
-      </p:sp>
-    </p:spTree>
-  </p:cSld>
-  <p:clrMapOvr>
-    <a:masterClrMapping/>
-  </p:clrMapOvr>
-</p:sld>
-</file>
-
-<file path=ppt/slides/slide48.xml><?xml version="1.0" encoding="utf-8"?>
-<p:sld xmlns:a="http://schemas.openxmlformats.org/drawingml/2006/main" xmlns:r="http://schemas.openxmlformats.org/officeDocument/2006/relationships" xmlns:p="http://schemas.openxmlformats.org/presentationml/2006/main">
-  <p:cSld name="Slide 48">
-    <p:spTree>
-      <p:nvGrpSpPr>
-        <p:cNvPr id="1" name=""/>
-        <p:cNvGrpSpPr/>
-        <p:nvPr/>
-      </p:nvGrpSpPr>
-      <p:grpSpPr>
-        <a:xfrm>
-          <a:off x="0" y="0"/>
-          <a:ext cx="0" cy="0"/>
-          <a:chOff x="0" y="0"/>
-          <a:chExt cx="0" cy="0"/>
-        </a:xfrm>
-      </p:grpSpPr>
-      <p:sp>
-        <p:nvSpPr>
-          <p:cNvPr id="2" name="Text 0"/>
-          <p:cNvSpPr/>
-          <p:nvPr/>
-        </p:nvSpPr>
-        <p:spPr>
-          <a:xfrm>
-            <a:off x="457200" y="713232"/>
-            <a:ext cx="11368735" cy="274320"/>
-          </a:xfrm>
-          <a:prstGeom prst="rect">
-            <a:avLst/>
-          </a:prstGeom>
-          <a:noFill/>
-          <a:ln/>
-        </p:spPr>
-        <p:txBody>
-          <a:bodyPr wrap="square" lIns="0" tIns="0" rIns="0" bIns="0" rtlCol="0" anchor="ctr"/>
-          <a:lstStyle/>
-          <a:p>
-            <a:pPr algn="r" indent="0" marL="0">
-              <a:buNone/>
-            </a:pPr>
-            <a:r>
-              <a:rPr lang="en-US" sz="1400" b="1" dirty="0">
-                <a:solidFill>
-                  <a:srgbClr val="1C3F6E"/>
-                </a:solidFill>
-                <a:latin typeface="Calibri" pitchFamily="34" charset="0"/>
-                <a:ea typeface="Calibri" pitchFamily="34" charset="-122"/>
-                <a:cs typeface="Calibri" pitchFamily="34" charset="-120"/>
-              </a:rPr>
-              <a:t>NEXT LESSON</a:t>
-            </a:r>
-            <a:endParaRPr lang="en-US" sz="1400" dirty="0"/>
-          </a:p>
-        </p:txBody>
-      </p:sp>
-      <p:pic>
-        <p:nvPicPr>
-          <p:cNvPr id="3" name="Image 0" descr="/home/claude/f4/img/minesec_sheet.png">    </p:cNvPr>
-          <p:cNvPicPr>
-            <a:picLocks noChangeAspect="1"/>
-          </p:cNvPicPr>
-          <p:nvPr/>
-        </p:nvPicPr>
-        <p:blipFill>
-          <a:blip r:embed="rId1"/>
-          <a:stretch>
-            <a:fillRect/>
-          </a:stretch>
-        </p:blipFill>
-        <p:spPr>
-          <a:xfrm>
-            <a:off x="0" y="658368"/>
-            <a:ext cx="5120640" cy="5833872"/>
-          </a:xfrm>
-          <a:prstGeom prst="rect">
-            <a:avLst/>
-          </a:prstGeom>
-        </p:spPr>
-      </p:pic>
-      <p:sp>
-        <p:nvSpPr>
-          <p:cNvPr id="4" name="Text 1"/>
-          <p:cNvSpPr/>
-          <p:nvPr/>
-        </p:nvSpPr>
-        <p:spPr>
-          <a:xfrm>
-            <a:off x="5349240" y="1005840"/>
-            <a:ext cx="6522415" cy="731520"/>
-          </a:xfrm>
-          <a:prstGeom prst="rect">
-            <a:avLst/>
-          </a:prstGeom>
-          <a:noFill/>
-          <a:ln/>
-        </p:spPr>
-        <p:txBody>
-          <a:bodyPr wrap="square" lIns="0" tIns="0" rIns="0" bIns="0" rtlCol="0" anchor="ctr">
-            <a:normAutofit/>
-          </a:bodyPr>
-          <a:lstStyle/>
-          <a:p>
-            <a:pPr algn="ctr" indent="0" marL="0">
-              <a:buNone/>
-            </a:pPr>
-            <a:r>
-              <a:rPr lang="en-US" sz="3600" b="1" dirty="0">
-                <a:solidFill>
-                  <a:srgbClr val="990011"/>
-                </a:solidFill>
-                <a:latin typeface="Times New Roman" pitchFamily="34" charset="0"/>
-                <a:ea typeface="Times New Roman" pitchFamily="34" charset="-122"/>
-                <a:cs typeface="Times New Roman" pitchFamily="34" charset="-120"/>
-              </a:rPr>
-              <a:t>Next Lesson</a:t>
-            </a:r>
-            <a:endParaRPr lang="en-US" sz="3600" dirty="0"/>
-          </a:p>
-        </p:txBody>
-      </p:sp>
-      <p:sp>
-        <p:nvSpPr>
-          <p:cNvPr id="5" name="Text 2"/>
-          <p:cNvSpPr/>
-          <p:nvPr/>
-        </p:nvSpPr>
-        <p:spPr>
-          <a:xfrm>
-            <a:off x="5349240" y="1783080"/>
-            <a:ext cx="6522415" cy="4663440"/>
-          </a:xfrm>
-          <a:prstGeom prst="rect">
-            <a:avLst/>
-          </a:prstGeom>
-          <a:noFill/>
-          <a:ln/>
-        </p:spPr>
-        <p:txBody>
-          <a:bodyPr wrap="square" lIns="0" tIns="0" rIns="0" bIns="0" rtlCol="0" anchor="ctr"/>
-          <a:lstStyle/>
-          <a:p>
-            <a:pPr algn="ctr" indent="0" marL="0">
-              <a:spcAft>
-                <a:spcPts val="800"/>
-              </a:spcAft>
-              <a:buNone/>
-            </a:pPr>
-            <a:r>
-              <a:rPr lang="en-US" sz="4000" b="1" dirty="0">
-                <a:solidFill>
-                  <a:srgbClr val="111111"/>
-                </a:solidFill>
-                <a:latin typeface="Times New Roman" pitchFamily="34" charset="0"/>
-                <a:ea typeface="Times New Roman" pitchFamily="34" charset="-122"/>
-                <a:cs typeface="Times New Roman" pitchFamily="34" charset="-120"/>
-              </a:rPr>
-              <a:t>Our next lesson will be on:</a:t>
-            </a:r>
-            <a:endParaRPr lang="en-US" sz="4000" dirty="0"/>
-          </a:p>
-          <a:p>
-            <a:pPr algn="ctr" indent="0" marL="0">
-              <a:spcAft>
-                <a:spcPts val="800"/>
-              </a:spcAft>
-              <a:buNone/>
-            </a:pPr>
-            <a:r>
-              <a:rPr lang="en-US" sz="4000" b="1" dirty="0">
-                <a:solidFill>
-                  <a:srgbClr val="990011"/>
-                </a:solidFill>
-                <a:latin typeface="Times New Roman" pitchFamily="34" charset="0"/>
-                <a:ea typeface="Times New Roman" pitchFamily="34" charset="-122"/>
-                <a:cs typeface="Times New Roman" pitchFamily="34" charset="-120"/>
-              </a:rPr>
-              <a:t>Lesson 1 (Part 2): The Equatorial Region: Characteristics (Soils and Vegetation)</a:t>
-            </a:r>
-            <a:endParaRPr lang="en-US" sz="4000" dirty="0"/>
-          </a:p>
-        </p:txBody>
-      </p:sp>
-      <p:sp>
-        <p:nvSpPr>
-          <p:cNvPr id="25" name="Slide Number Placeholder 0"/>
-          <p:cNvSpPr>
-            <a:spLocks noGrp="1"/>
-          </p:cNvSpPr>
-          <p:nvPr>
-            <p:ph type="sldNum" sz="quarter" idx="4294967295"/>
-          </p:nvPr>
-        </p:nvSpPr>
-        <p:spPr>
-          <a:xfrm>
-            <a:off x="27432" y="91440"/>
-            <a:ext cx="585216" cy="475488"/>
-          </a:xfrm>
-          <a:prstGeom prst="rect">
-            <a:avLst/>
-          </a:prstGeom>
-          <a:extLst>
-            <a:ext uri="{C572A759-6A51-4108-AA02-DFA0A04FC94B}">
-              <ma14:wrappingTextBoxFlag xmlns:ma14="http://schemas.microsoft.com/office/mac/drawingml/2011/main" val="0"/>
-            </a:ext>
-          </a:extLst>
-        </p:spPr>
-        <p:txBody>
-          <a:bodyPr/>
-          <a:lstStyle>
-            <a:lvl1pPr>
-              <a:defRPr sz="2000">
-                <a:solidFill>
-                  <a:srgbClr val="FFFFFF"/>
-                </a:solidFill>
-                <a:latin typeface="Calibri"/>
-                <a:ea typeface="Calibri"/>
-                <a:cs typeface="Calibri"/>
-              </a:defRPr>
-            </a:lvl1pPr>
-          </a:lstStyle>
-          <a:p>
-            <a:pPr algn="ctr"/>
-            <a:fld id="{F7021451-1387-4CA6-816F-3879F97B5CBC}" type="slidenum">
-              <a:rPr b="1" lang="en-US"/>
-              <a:t>48</a:t>
-            </a:fld>
-            <a:endParaRPr lang="en-US"/>
-          </a:p>
-        </p:txBody>
-      </p:sp>
-    </p:spTree>
-  </p:cSld>
-  <p:clrMapOvr>
-    <a:masterClrMapping/>
-  </p:clrMapOvr>
-</p:sld>
-</file>
-
-<file path=ppt/slides/slide49.xml><?xml version="1.0" encoding="utf-8"?>
-<p:sld xmlns:a="http://schemas.openxmlformats.org/drawingml/2006/main" xmlns:r="http://schemas.openxmlformats.org/officeDocument/2006/relationships" xmlns:p="http://schemas.openxmlformats.org/presentationml/2006/main">
-  <p:cSld name="Slide 49">
-    <p:spTree>
-      <p:nvGrpSpPr>
-        <p:cNvPr id="1" name=""/>
-        <p:cNvGrpSpPr/>
-        <p:nvPr/>
-      </p:nvGrpSpPr>
-      <p:grpSpPr>
-        <a:xfrm>
-          <a:off x="0" y="0"/>
-          <a:ext cx="0" cy="0"/>
-          <a:chOff x="0" y="0"/>
-          <a:chExt cx="0" cy="0"/>
-        </a:xfrm>
-      </p:grpSpPr>
-      <p:sp>
-        <p:nvSpPr>
-          <p:cNvPr id="2" name="Text 0"/>
-          <p:cNvSpPr/>
-          <p:nvPr/>
-        </p:nvSpPr>
-        <p:spPr>
-          <a:xfrm>
-            <a:off x="457200" y="713232"/>
-            <a:ext cx="11368735" cy="274320"/>
-          </a:xfrm>
-          <a:prstGeom prst="rect">
-            <a:avLst/>
-          </a:prstGeom>
-          <a:noFill/>
-          <a:ln/>
-        </p:spPr>
-        <p:txBody>
-          <a:bodyPr wrap="square" lIns="0" tIns="0" rIns="0" bIns="0" rtlCol="0" anchor="ctr"/>
-          <a:lstStyle/>
-          <a:p>
-            <a:pPr algn="r" indent="0" marL="0">
-              <a:buNone/>
-            </a:pPr>
-            <a:r>
-              <a:rPr lang="en-US" sz="1400" b="1" dirty="0">
-                <a:solidFill>
-                  <a:srgbClr val="1C3F6E"/>
-                </a:solidFill>
-                <a:latin typeface="Calibri" pitchFamily="34" charset="0"/>
-                <a:ea typeface="Calibri" pitchFamily="34" charset="-122"/>
-                <a:cs typeface="Calibri" pitchFamily="34" charset="-120"/>
-              </a:rPr>
               <a:t>BILINGUAL GAME</a:t>
             </a:r>
             <a:endParaRPr lang="en-US" sz="1400" dirty="0"/>
@@ -17538,7 +16861,7 @@
       </p:sp>
       <p:graphicFrame>
         <p:nvGraphicFramePr>
-          <p:cNvPr id="50" name="Table 0"/>
+          <p:cNvPr id="48" name="Table 0"/>
           <p:cNvGraphicFramePr>
             <a:graphicFrameLocks noGrp="1"/>
           </p:cNvGraphicFramePr>
@@ -18574,7 +17897,7 @@
             <a:pPr algn="ctr"/>
             <a:fld id="{F7021451-1387-4CA6-816F-3879F97B5CBC}" type="slidenum">
               <a:rPr b="1" lang="en-US"/>
-              <a:t>49</a:t>
+              <a:t>47</a:t>
             </a:fld>
             <a:endParaRPr lang="en-US"/>
           </a:p>
@@ -18588,9 +17911,9 @@
 </p:sld>
 </file>
 
-<file path=ppt/slides/slide5.xml><?xml version="1.0" encoding="utf-8"?>
+<file path=ppt/slides/slide48.xml><?xml version="1.0" encoding="utf-8"?>
 <p:sld xmlns:a="http://schemas.openxmlformats.org/drawingml/2006/main" xmlns:r="http://schemas.openxmlformats.org/officeDocument/2006/relationships" xmlns:p="http://schemas.openxmlformats.org/presentationml/2006/main">
-  <p:cSld name="Slide 5">
+  <p:cSld name="Slide 48">
     <p:spTree>
       <p:nvGrpSpPr>
         <p:cNvPr id="1" name=""/>
@@ -18638,269 +17961,6 @@
                 <a:ea typeface="Calibri" pitchFamily="34" charset="-122"/>
                 <a:cs typeface="Calibri" pitchFamily="34" charset="-120"/>
               </a:rPr>
-              <a:t>OBJECTIVES</a:t>
-            </a:r>
-            <a:endParaRPr lang="en-US" sz="1400" dirty="0"/>
-          </a:p>
-        </p:txBody>
-      </p:sp>
-      <p:pic>
-        <p:nvPicPr>
-          <p:cNvPr id="3" name="Image 0" descr="/home/claude/f4/img/minesec_sheet.png">    </p:cNvPr>
-          <p:cNvPicPr>
-            <a:picLocks noChangeAspect="1"/>
-          </p:cNvPicPr>
-          <p:nvPr/>
-        </p:nvPicPr>
-        <p:blipFill>
-          <a:blip r:embed="rId1"/>
-          <a:stretch>
-            <a:fillRect/>
-          </a:stretch>
-        </p:blipFill>
-        <p:spPr>
-          <a:xfrm>
-            <a:off x="0" y="658368"/>
-            <a:ext cx="2468880" cy="5833872"/>
-          </a:xfrm>
-          <a:prstGeom prst="rect">
-            <a:avLst/>
-          </a:prstGeom>
-        </p:spPr>
-      </p:pic>
-      <p:sp>
-        <p:nvSpPr>
-          <p:cNvPr id="4" name="Text 1"/>
-          <p:cNvSpPr/>
-          <p:nvPr/>
-        </p:nvSpPr>
-        <p:spPr>
-          <a:xfrm>
-            <a:off x="2697480" y="1005840"/>
-            <a:ext cx="9174175" cy="731520"/>
-          </a:xfrm>
-          <a:prstGeom prst="rect">
-            <a:avLst/>
-          </a:prstGeom>
-          <a:noFill/>
-          <a:ln/>
-        </p:spPr>
-        <p:txBody>
-          <a:bodyPr wrap="square" lIns="0" tIns="0" rIns="0" bIns="0" rtlCol="0" anchor="ctr">
-            <a:normAutofit/>
-          </a:bodyPr>
-          <a:lstStyle/>
-          <a:p>
-            <a:pPr algn="ctr" indent="0" marL="0">
-              <a:buNone/>
-            </a:pPr>
-            <a:r>
-              <a:rPr lang="en-US" sz="3600" b="1" dirty="0">
-                <a:solidFill>
-                  <a:srgbClr val="990011"/>
-                </a:solidFill>
-                <a:latin typeface="Times New Roman" pitchFamily="34" charset="0"/>
-                <a:ea typeface="Times New Roman" pitchFamily="34" charset="-122"/>
-                <a:cs typeface="Times New Roman" pitchFamily="34" charset="-120"/>
-              </a:rPr>
-              <a:t>Objectives</a:t>
-            </a:r>
-            <a:endParaRPr lang="en-US" sz="3600" dirty="0"/>
-          </a:p>
-        </p:txBody>
-      </p:sp>
-      <p:sp>
-        <p:nvSpPr>
-          <p:cNvPr id="5" name="Text 2"/>
-          <p:cNvSpPr/>
-          <p:nvPr/>
-        </p:nvSpPr>
-        <p:spPr>
-          <a:xfrm>
-            <a:off x="2697480" y="1783080"/>
-            <a:ext cx="9174175" cy="4663440"/>
-          </a:xfrm>
-          <a:prstGeom prst="rect">
-            <a:avLst/>
-          </a:prstGeom>
-          <a:noFill/>
-          <a:ln/>
-        </p:spPr>
-        <p:txBody>
-          <a:bodyPr wrap="square" lIns="0" tIns="0" rIns="0" bIns="0" rtlCol="0" anchor="t"/>
-          <a:lstStyle/>
-          <a:p>
-            <a:pPr algn="l" indent="0" marL="0">
-              <a:spcAft>
-                <a:spcPts val="800"/>
-              </a:spcAft>
-              <a:buNone/>
-            </a:pPr>
-            <a:r>
-              <a:rPr lang="en-US" sz="4000" b="1" dirty="0">
-                <a:solidFill>
-                  <a:srgbClr val="111111"/>
-                </a:solidFill>
-                <a:latin typeface="Times New Roman" pitchFamily="34" charset="0"/>
-                <a:ea typeface="Times New Roman" pitchFamily="34" charset="-122"/>
-                <a:cs typeface="Times New Roman" pitchFamily="34" charset="-120"/>
-              </a:rPr>
-              <a:t>By the end of this lesson, you should be able to:</a:t>
-            </a:r>
-            <a:endParaRPr lang="en-US" sz="4000" dirty="0"/>
-          </a:p>
-          <a:p>
-            <a:pPr algn="l" marL="342900" indent="-342900">
-              <a:spcAft>
-                <a:spcPts val="800"/>
-              </a:spcAft>
-              <a:buSzPct val="100000"/>
-              <a:buFont typeface="+mj-lt"/>
-              <a:buAutoNum type="arabicPeriod" startAt="1"/>
-            </a:pPr>
-            <a:r>
-              <a:rPr lang="en-US" sz="4000" dirty="0">
-                <a:solidFill>
-                  <a:srgbClr val="111111"/>
-                </a:solidFill>
-                <a:latin typeface="Times New Roman" pitchFamily="34" charset="0"/>
-                <a:ea typeface="Times New Roman" pitchFamily="34" charset="-122"/>
-                <a:cs typeface="Times New Roman" pitchFamily="34" charset="-120"/>
-              </a:rPr>
-              <a:t>Locate the Equatorial region on a map of the world and of Africa.</a:t>
-            </a:r>
-            <a:endParaRPr lang="en-US" sz="4000" dirty="0"/>
-          </a:p>
-          <a:p>
-            <a:pPr algn="l" marL="342900" indent="-342900">
-              <a:spcAft>
-                <a:spcPts val="800"/>
-              </a:spcAft>
-              <a:buSzPct val="100000"/>
-              <a:buFont typeface="+mj-lt"/>
-              <a:buAutoNum type="arabicPeriod" startAt="1"/>
-            </a:pPr>
-            <a:r>
-              <a:rPr lang="en-US" sz="4000" dirty="0">
-                <a:solidFill>
-                  <a:srgbClr val="111111"/>
-                </a:solidFill>
-                <a:latin typeface="Times New Roman" pitchFamily="34" charset="0"/>
-                <a:ea typeface="Times New Roman" pitchFamily="34" charset="-122"/>
-                <a:cs typeface="Times New Roman" pitchFamily="34" charset="-120"/>
-              </a:rPr>
-              <a:t>Describe the temperature and the rainfall of the Equatorial region.</a:t>
-            </a:r>
-            <a:endParaRPr lang="en-US" sz="4000" dirty="0"/>
-          </a:p>
-        </p:txBody>
-      </p:sp>
-      <p:sp>
-        <p:nvSpPr>
-          <p:cNvPr id="25" name="Slide Number Placeholder 0"/>
-          <p:cNvSpPr>
-            <a:spLocks noGrp="1"/>
-          </p:cNvSpPr>
-          <p:nvPr>
-            <p:ph type="sldNum" sz="quarter" idx="4294967295"/>
-          </p:nvPr>
-        </p:nvSpPr>
-        <p:spPr>
-          <a:xfrm>
-            <a:off x="27432" y="91440"/>
-            <a:ext cx="585216" cy="475488"/>
-          </a:xfrm>
-          <a:prstGeom prst="rect">
-            <a:avLst/>
-          </a:prstGeom>
-          <a:extLst>
-            <a:ext uri="{C572A759-6A51-4108-AA02-DFA0A04FC94B}">
-              <ma14:wrappingTextBoxFlag xmlns:ma14="http://schemas.microsoft.com/office/mac/drawingml/2011/main" val="0"/>
-            </a:ext>
-          </a:extLst>
-        </p:spPr>
-        <p:txBody>
-          <a:bodyPr/>
-          <a:lstStyle>
-            <a:lvl1pPr>
-              <a:defRPr sz="2000">
-                <a:solidFill>
-                  <a:srgbClr val="FFFFFF"/>
-                </a:solidFill>
-                <a:latin typeface="Calibri"/>
-                <a:ea typeface="Calibri"/>
-                <a:cs typeface="Calibri"/>
-              </a:defRPr>
-            </a:lvl1pPr>
-          </a:lstStyle>
-          <a:p>
-            <a:pPr algn="ctr"/>
-            <a:fld id="{F7021451-1387-4CA6-816F-3879F97B5CBC}" type="slidenum">
-              <a:rPr b="1" lang="en-US"/>
-              <a:t>5</a:t>
-            </a:fld>
-            <a:endParaRPr lang="en-US"/>
-          </a:p>
-        </p:txBody>
-      </p:sp>
-    </p:spTree>
-  </p:cSld>
-  <p:clrMapOvr>
-    <a:masterClrMapping/>
-  </p:clrMapOvr>
-</p:sld>
-</file>
-
-<file path=ppt/slides/slide50.xml><?xml version="1.0" encoding="utf-8"?>
-<p:sld xmlns:a="http://schemas.openxmlformats.org/drawingml/2006/main" xmlns:r="http://schemas.openxmlformats.org/officeDocument/2006/relationships" xmlns:p="http://schemas.openxmlformats.org/presentationml/2006/main">
-  <p:cSld name="Slide 50">
-    <p:spTree>
-      <p:nvGrpSpPr>
-        <p:cNvPr id="1" name=""/>
-        <p:cNvGrpSpPr/>
-        <p:nvPr/>
-      </p:nvGrpSpPr>
-      <p:grpSpPr>
-        <a:xfrm>
-          <a:off x="0" y="0"/>
-          <a:ext cx="0" cy="0"/>
-          <a:chOff x="0" y="0"/>
-          <a:chExt cx="0" cy="0"/>
-        </a:xfrm>
-      </p:grpSpPr>
-      <p:sp>
-        <p:nvSpPr>
-          <p:cNvPr id="2" name="Text 0"/>
-          <p:cNvSpPr/>
-          <p:nvPr/>
-        </p:nvSpPr>
-        <p:spPr>
-          <a:xfrm>
-            <a:off x="457200" y="713232"/>
-            <a:ext cx="11368735" cy="274320"/>
-          </a:xfrm>
-          <a:prstGeom prst="rect">
-            <a:avLst/>
-          </a:prstGeom>
-          <a:noFill/>
-          <a:ln/>
-        </p:spPr>
-        <p:txBody>
-          <a:bodyPr wrap="square" lIns="0" tIns="0" rIns="0" bIns="0" rtlCol="0" anchor="ctr"/>
-          <a:lstStyle/>
-          <a:p>
-            <a:pPr algn="r" indent="0" marL="0">
-              <a:buNone/>
-            </a:pPr>
-            <a:r>
-              <a:rPr lang="en-US" sz="1400" b="1" dirty="0">
-                <a:solidFill>
-                  <a:srgbClr val="1C3F6E"/>
-                </a:solidFill>
-                <a:latin typeface="Calibri" pitchFamily="34" charset="0"/>
-                <a:ea typeface="Calibri" pitchFamily="34" charset="-122"/>
-                <a:cs typeface="Calibri" pitchFamily="34" charset="-120"/>
-              </a:rPr>
               <a:t>LOGBOOK</a:t>
             </a:r>
             <a:endParaRPr lang="en-US" sz="1400" dirty="0"/>
@@ -18948,7 +18008,7 @@
       </p:sp>
       <p:graphicFrame>
         <p:nvGraphicFramePr>
-          <p:cNvPr id="51" name="Table 0"/>
+          <p:cNvPr id="49" name="Table 0"/>
           <p:cNvGraphicFramePr>
             <a:graphicFrameLocks noGrp="1"/>
           </p:cNvGraphicFramePr>
@@ -19570,7 +18630,7 @@
             <a:pPr algn="ctr"/>
             <a:fld id="{F7021451-1387-4CA6-816F-3879F97B5CBC}" type="slidenum">
               <a:rPr b="1" lang="en-US"/>
-              <a:t>50</a:t>
+              <a:t>48</a:t>
             </a:fld>
             <a:endParaRPr lang="en-US"/>
           </a:p>
@@ -19584,9 +18644,9 @@
 </p:sld>
 </file>
 
-<file path=ppt/slides/slide51.xml><?xml version="1.0" encoding="utf-8"?>
+<file path=ppt/slides/slide49.xml><?xml version="1.0" encoding="utf-8"?>
 <p:sld xmlns:a="http://schemas.openxmlformats.org/drawingml/2006/main" xmlns:r="http://schemas.openxmlformats.org/officeDocument/2006/relationships" xmlns:p="http://schemas.openxmlformats.org/presentationml/2006/main">
-  <p:cSld name="Slide 51">
+  <p:cSld name="Slide 49">
     <p:spTree>
       <p:nvGrpSpPr>
         <p:cNvPr id="1" name=""/>
@@ -19681,7 +18741,7 @@
       </p:sp>
       <p:graphicFrame>
         <p:nvGraphicFramePr>
-          <p:cNvPr id="52" name="Table 0"/>
+          <p:cNvPr id="50" name="Table 0"/>
           <p:cNvGraphicFramePr>
             <a:graphicFrameLocks noGrp="1"/>
           </p:cNvGraphicFramePr>
@@ -19791,7 +18851,7 @@
                           <a:ea typeface="Calibri" pitchFamily="34" charset="-122"/>
                           <a:cs typeface="Calibri" pitchFamily="34" charset="-120"/>
                         </a:rPr>
-                        <a:t>Meaning; Location; Characteristics of the Climate.</a:t>
+                        <a:t>DEFINITIONS; Location; Characteristics of the Climate.</a:t>
                       </a:r>
                       <a:endParaRPr lang="en-US" sz="1600" dirty="0">
                         <a:latin typeface="Calibri" charset="0"/>
@@ -20441,7 +19501,7 @@
             <a:pPr algn="ctr"/>
             <a:fld id="{F7021451-1387-4CA6-816F-3879F97B5CBC}" type="slidenum">
               <a:rPr b="1" lang="en-US"/>
-              <a:t>51</a:t>
+              <a:t>49</a:t>
             </a:fld>
             <a:endParaRPr lang="en-US"/>
           </a:p>
@@ -20455,9 +19515,9 @@
 </p:sld>
 </file>
 
-<file path=ppt/slides/slide52.xml><?xml version="1.0" encoding="utf-8"?>
+<file path=ppt/slides/slide5.xml><?xml version="1.0" encoding="utf-8"?>
 <p:sld xmlns:a="http://schemas.openxmlformats.org/drawingml/2006/main" xmlns:r="http://schemas.openxmlformats.org/officeDocument/2006/relationships" xmlns:p="http://schemas.openxmlformats.org/presentationml/2006/main">
-  <p:cSld name="Slide 52">
+  <p:cSld name="Slide 5">
     <p:spTree>
       <p:nvGrpSpPr>
         <p:cNvPr id="1" name=""/>
@@ -20505,7 +19565,7 @@
                 <a:ea typeface="Calibri" pitchFamily="34" charset="-122"/>
                 <a:cs typeface="Calibri" pitchFamily="34" charset="-120"/>
               </a:rPr>
-              <a:t>TEACHER'S NOTE</a:t>
+              <a:t>OBJECTIVES</a:t>
             </a:r>
             <a:endParaRPr lang="en-US" sz="1400" dirty="0"/>
           </a:p>
@@ -20528,7 +19588,7 @@
         <p:spPr>
           <a:xfrm>
             <a:off x="0" y="658368"/>
-            <a:ext cx="1463040" cy="5833872"/>
+            <a:ext cx="2468880" cy="5833872"/>
           </a:xfrm>
           <a:prstGeom prst="rect">
             <a:avLst/>
@@ -20543,8 +19603,8 @@
         </p:nvSpPr>
         <p:spPr>
           <a:xfrm>
-            <a:off x="1691640" y="1005840"/>
-            <a:ext cx="10180015" cy="731520"/>
+            <a:off x="2697480" y="1005840"/>
+            <a:ext cx="9174175" cy="731520"/>
           </a:xfrm>
           <a:prstGeom prst="rect">
             <a:avLst/>
@@ -20570,7 +19630,7 @@
                 <a:ea typeface="Times New Roman" pitchFamily="34" charset="-122"/>
                 <a:cs typeface="Times New Roman" pitchFamily="34" charset="-120"/>
               </a:rPr>
-              <a:t>Teacher's Note</a:t>
+              <a:t>Objectives</a:t>
             </a:r>
             <a:endParaRPr lang="en-US" sz="3600" dirty="0"/>
           </a:p>
@@ -20584,8 +19644,8 @@
         </p:nvSpPr>
         <p:spPr>
           <a:xfrm>
-            <a:off x="1691640" y="1783080"/>
-            <a:ext cx="10180015" cy="4663440"/>
+            <a:off x="2697480" y="1783080"/>
+            <a:ext cx="9174175" cy="4663440"/>
           </a:xfrm>
           <a:prstGeom prst="rect">
             <a:avLst/>
@@ -20596,26 +19656,47 @@
         <p:txBody>
           <a:bodyPr wrap="square" lIns="0" tIns="0" rIns="0" bIns="0" rtlCol="0" anchor="t"/>
           <a:lstStyle/>
+          <a:p>
+            <a:pPr algn="l" indent="0" marL="0">
+              <a:spcAft>
+                <a:spcPts val="800"/>
+              </a:spcAft>
+              <a:buNone/>
+            </a:pPr>
+            <a:r>
+              <a:rPr lang="en-US" sz="4000" b="1" dirty="0">
+                <a:solidFill>
+                  <a:srgbClr val="111111"/>
+                </a:solidFill>
+                <a:latin typeface="Times New Roman" pitchFamily="34" charset="0"/>
+                <a:ea typeface="Times New Roman" pitchFamily="34" charset="-122"/>
+                <a:cs typeface="Times New Roman" pitchFamily="34" charset="-120"/>
+              </a:rPr>
+              <a:t>By the end of this lesson, you should be able to:</a:t>
+            </a:r>
+            <a:endParaRPr lang="en-US" sz="4000" dirty="0"/>
+          </a:p>
           <a:p>
             <a:pPr algn="l" marL="342900" indent="-342900">
               <a:spcAft>
                 <a:spcPts val="800"/>
               </a:spcAft>
               <a:buSzPct val="100000"/>
-              <a:buChar char="•"/>
+              <a:buFont typeface="+mj-lt"/>
+              <a:buAutoNum type="arabicPeriod" startAt="1"/>
             </a:pPr>
             <a:r>
-              <a:rPr lang="en-US" sz="2000" dirty="0">
+              <a:rPr lang="en-US" sz="4000" dirty="0">
                 <a:solidFill>
                   <a:srgbClr val="111111"/>
                 </a:solidFill>
-                <a:latin typeface="Calibri" pitchFamily="34" charset="0"/>
-                <a:ea typeface="Calibri" pitchFamily="34" charset="-122"/>
-                <a:cs typeface="Calibri" pitchFamily="34" charset="-120"/>
+                <a:latin typeface="Times New Roman" pitchFamily="34" charset="0"/>
+                <a:ea typeface="Times New Roman" pitchFamily="34" charset="-122"/>
+                <a:cs typeface="Times New Roman" pitchFamily="34" charset="-120"/>
               </a:rPr>
-              <a:t>Timing: Homework correction, plan, objectives 8 min | Recall, situation, action 10 min | 5 activities 30 min | Board summary (copying) 30 min | Evaluation, remediation 10 min | Homework, next lesson 5 min | Logbook 7 min</a:t>
-            </a:r>
-            <a:endParaRPr lang="en-US" sz="2000" dirty="0"/>
+              <a:t>Locate the Equatorial region on a map of the world and of Africa.</a:t>
+            </a:r>
+            <a:endParaRPr lang="en-US" sz="4000" dirty="0"/>
           </a:p>
           <a:p>
             <a:pPr algn="l" marL="342900" indent="-342900">
@@ -20623,104 +19704,21 @@
                 <a:spcPts val="800"/>
               </a:spcAft>
               <a:buSzPct val="100000"/>
-              <a:buChar char="•"/>
+              <a:buFont typeface="+mj-lt"/>
+              <a:buAutoNum type="arabicPeriod" startAt="1"/>
             </a:pPr>
             <a:r>
-              <a:rPr lang="en-US" sz="2000" dirty="0">
+              <a:rPr lang="en-US" sz="4000" dirty="0">
                 <a:solidFill>
                   <a:srgbClr val="111111"/>
                 </a:solidFill>
-                <a:latin typeface="Calibri" pitchFamily="34" charset="0"/>
-                <a:ea typeface="Calibri" pitchFamily="34" charset="-122"/>
-                <a:cs typeface="Calibri" pitchFamily="34" charset="-120"/>
+                <a:latin typeface="Times New Roman" pitchFamily="34" charset="0"/>
+                <a:ea typeface="Times New Roman" pitchFamily="34" charset="-122"/>
+                <a:cs typeface="Times New Roman" pitchFamily="34" charset="-120"/>
               </a:rPr>
-              <a:t>Yaoundé (Central Region) has two rainy seasons (March–June and September–November); Douala, near Mount Cameroon, receives about 4,000 mm of rain a year.</a:t>
-            </a:r>
-            <a:endParaRPr lang="en-US" sz="2000" dirty="0"/>
-          </a:p>
-          <a:p>
-            <a:pPr algn="l" marL="342900" indent="-342900">
-              <a:spcAft>
-                <a:spcPts val="800"/>
-              </a:spcAft>
-              <a:buSzPct val="100000"/>
-              <a:buChar char="•"/>
-            </a:pPr>
-            <a:r>
-              <a:rPr lang="en-US" sz="2000" dirty="0">
-                <a:solidFill>
-                  <a:srgbClr val="111111"/>
-                </a:solidFill>
-                <a:latin typeface="Calibri" pitchFamily="34" charset="0"/>
-                <a:ea typeface="Calibri" pitchFamily="34" charset="-122"/>
-                <a:cs typeface="Calibri" pitchFamily="34" charset="-120"/>
-              </a:rPr>
-              <a:t>Without the projector (Activity 1): ask learners who have travelled south to describe the forest.</a:t>
-            </a:r>
-            <a:endParaRPr lang="en-US" sz="2000" dirty="0"/>
-          </a:p>
-          <a:p>
-            <a:pPr algn="l" marL="342900" indent="-342900">
-              <a:spcAft>
-                <a:spcPts val="800"/>
-              </a:spcAft>
-              <a:buSzPct val="100000"/>
-              <a:buChar char="•"/>
-            </a:pPr>
-            <a:r>
-              <a:rPr lang="en-US" sz="2000" dirty="0">
-                <a:solidFill>
-                  <a:srgbClr val="111111"/>
-                </a:solidFill>
-                <a:latin typeface="Calibri" pitchFamily="34" charset="0"/>
-                <a:ea typeface="Calibri" pitchFamily="34" charset="-122"/>
-                <a:cs typeface="Calibri" pitchFamily="34" charset="-120"/>
-              </a:rPr>
-              <a:t>Without the projector (Activity 2): draw the Equator and two lines at 5° N and 5° S on the board.</a:t>
-            </a:r>
-            <a:endParaRPr lang="en-US" sz="2000" dirty="0"/>
-          </a:p>
-          <a:p>
-            <a:pPr algn="l" marL="342900" indent="-342900">
-              <a:spcAft>
-                <a:spcPts val="800"/>
-              </a:spcAft>
-              <a:buSzPct val="100000"/>
-              <a:buChar char="•"/>
-            </a:pPr>
-            <a:r>
-              <a:rPr lang="en-US" sz="2000" dirty="0">
-                <a:solidFill>
-                  <a:srgbClr val="111111"/>
-                </a:solidFill>
-                <a:latin typeface="Calibri" pitchFamily="34" charset="0"/>
-                <a:ea typeface="Calibri" pitchFamily="34" charset="-122"/>
-                <a:cs typeface="Calibri" pitchFamily="34" charset="-120"/>
-              </a:rPr>
-              <a:t>Without the projector (Activity 3): write the monthly temperatures of Yaoundé on the board.</a:t>
-            </a:r>
-            <a:endParaRPr lang="en-US" sz="2000" dirty="0"/>
-          </a:p>
-          <a:p>
-            <a:pPr algn="l" marL="342900" indent="-342900">
-              <a:spcAft>
-                <a:spcPts val="800"/>
-              </a:spcAft>
-              <a:buSzPct val="100000"/>
-              <a:buChar char="•"/>
-            </a:pPr>
-            <a:r>
-              <a:rPr lang="en-US" sz="2000" dirty="0">
-                <a:solidFill>
-                  <a:srgbClr val="111111"/>
-                </a:solidFill>
-                <a:latin typeface="Calibri" pitchFamily="34" charset="0"/>
-                <a:ea typeface="Calibri" pitchFamily="34" charset="-122"/>
-                <a:cs typeface="Calibri" pitchFamily="34" charset="-120"/>
-              </a:rPr>
-              <a:t>Without the projector (Activity 4): write the monthly rainfall of Yaoundé on the board.</a:t>
-            </a:r>
-            <a:endParaRPr lang="en-US" sz="2000" dirty="0"/>
+              <a:t>Describe the temperature and the rainfall of the Equatorial region.</a:t>
+            </a:r>
+            <a:endParaRPr lang="en-US" sz="4000" dirty="0"/>
           </a:p>
         </p:txBody>
       </p:sp>
@@ -20766,7 +19764,7 @@
             <a:pPr algn="ctr"/>
             <a:fld id="{F7021451-1387-4CA6-816F-3879F97B5CBC}" type="slidenum">
               <a:rPr b="1" lang="en-US"/>
-              <a:t>52</a:t>
+              <a:t>5</a:t>
             </a:fld>
             <a:endParaRPr lang="en-US"/>
           </a:p>
@@ -20780,9 +19778,9 @@
 </p:sld>
 </file>
 
-<file path=ppt/slides/slide53.xml><?xml version="1.0" encoding="utf-8"?>
+<file path=ppt/slides/slide50.xml><?xml version="1.0" encoding="utf-8"?>
 <p:sld xmlns:a="http://schemas.openxmlformats.org/drawingml/2006/main" xmlns:r="http://schemas.openxmlformats.org/officeDocument/2006/relationships" xmlns:p="http://schemas.openxmlformats.org/presentationml/2006/main">
-  <p:cSld name="Slide 53">
+  <p:cSld name="Slide 50">
     <p:spTree>
       <p:nvGrpSpPr>
         <p:cNvPr id="1" name=""/>
@@ -20853,7 +19851,7 @@
         <p:spPr>
           <a:xfrm>
             <a:off x="0" y="658368"/>
-            <a:ext cx="5120640" cy="5833872"/>
+            <a:ext cx="2468880" cy="5833872"/>
           </a:xfrm>
           <a:prstGeom prst="rect">
             <a:avLst/>
@@ -20868,8 +19866,8 @@
         </p:nvSpPr>
         <p:spPr>
           <a:xfrm>
-            <a:off x="5349240" y="1005840"/>
-            <a:ext cx="6522415" cy="731520"/>
+            <a:off x="2697480" y="1005840"/>
+            <a:ext cx="9174175" cy="731520"/>
           </a:xfrm>
           <a:prstGeom prst="rect">
             <a:avLst/>
@@ -20895,7 +19893,7 @@
                 <a:ea typeface="Times New Roman" pitchFamily="34" charset="-122"/>
                 <a:cs typeface="Times New Roman" pitchFamily="34" charset="-120"/>
               </a:rPr>
-              <a:t>Teacher's Note (continued)</a:t>
+              <a:t>Teacher's Note</a:t>
             </a:r>
             <a:endParaRPr lang="en-US" sz="3600" dirty="0"/>
           </a:p>
@@ -20909,8 +19907,8 @@
         </p:nvSpPr>
         <p:spPr>
           <a:xfrm>
-            <a:off x="5349240" y="1783080"/>
-            <a:ext cx="6522415" cy="4663440"/>
+            <a:off x="2697480" y="1783080"/>
+            <a:ext cx="9174175" cy="4663440"/>
           </a:xfrm>
           <a:prstGeom prst="rect">
             <a:avLst/>
@@ -20938,7 +19936,133 @@
                 <a:ea typeface="Calibri" pitchFamily="34" charset="-122"/>
                 <a:cs typeface="Calibri" pitchFamily="34" charset="-120"/>
               </a:rPr>
-              <a:t>Without the projector (Activity 5): describe an afternoon storm in the rainy season.</a:t>
+              <a:t>Timing: Homework correction, plan, objectives 8 min | Recall, situation, action 10 min | 5 activities 30 min | Board summary (copying) 30 min | Evaluation, remediation 10 min | Homework, next lesson 5 min | Logbook 7 min</a:t>
+            </a:r>
+            <a:endParaRPr lang="en-US" sz="2000" dirty="0"/>
+          </a:p>
+          <a:p>
+            <a:pPr algn="l" marL="342900" indent="-342900">
+              <a:spcAft>
+                <a:spcPts val="800"/>
+              </a:spcAft>
+              <a:buSzPct val="100000"/>
+              <a:buChar char="•"/>
+            </a:pPr>
+            <a:r>
+              <a:rPr lang="en-US" sz="2000" dirty="0">
+                <a:solidFill>
+                  <a:srgbClr val="111111"/>
+                </a:solidFill>
+                <a:latin typeface="Calibri" pitchFamily="34" charset="0"/>
+                <a:ea typeface="Calibri" pitchFamily="34" charset="-122"/>
+                <a:cs typeface="Calibri" pitchFamily="34" charset="-120"/>
+              </a:rPr>
+              <a:t>Yaoundé (Central Region) has two rainy seasons (March–June and September–November); Douala, near Mount Cameroon, receives about 4,000 mm of rain a year.</a:t>
+            </a:r>
+            <a:endParaRPr lang="en-US" sz="2000" dirty="0"/>
+          </a:p>
+          <a:p>
+            <a:pPr algn="l" marL="342900" indent="-342900">
+              <a:spcAft>
+                <a:spcPts val="800"/>
+              </a:spcAft>
+              <a:buSzPct val="100000"/>
+              <a:buChar char="•"/>
+            </a:pPr>
+            <a:r>
+              <a:rPr lang="en-US" sz="2000" dirty="0">
+                <a:solidFill>
+                  <a:srgbClr val="111111"/>
+                </a:solidFill>
+                <a:latin typeface="Calibri" pitchFamily="34" charset="0"/>
+                <a:ea typeface="Calibri" pitchFamily="34" charset="-122"/>
+                <a:cs typeface="Calibri" pitchFamily="34" charset="-120"/>
+              </a:rPr>
+              <a:t>Without the projector (Activity 1): describe the forest of the South.</a:t>
+            </a:r>
+            <a:endParaRPr lang="en-US" sz="2000" dirty="0"/>
+          </a:p>
+          <a:p>
+            <a:pPr algn="l" marL="342900" indent="-342900">
+              <a:spcAft>
+                <a:spcPts val="800"/>
+              </a:spcAft>
+              <a:buSzPct val="100000"/>
+              <a:buChar char="•"/>
+            </a:pPr>
+            <a:r>
+              <a:rPr lang="en-US" sz="2000" dirty="0">
+                <a:solidFill>
+                  <a:srgbClr val="111111"/>
+                </a:solidFill>
+                <a:latin typeface="Calibri" pitchFamily="34" charset="0"/>
+                <a:ea typeface="Calibri" pitchFamily="34" charset="-122"/>
+                <a:cs typeface="Calibri" pitchFamily="34" charset="-120"/>
+              </a:rPr>
+              <a:t>Without the projector (Activity 2): draw the Equator on the board.</a:t>
+            </a:r>
+            <a:endParaRPr lang="en-US" sz="2000" dirty="0"/>
+          </a:p>
+          <a:p>
+            <a:pPr algn="l" marL="342900" indent="-342900">
+              <a:spcAft>
+                <a:spcPts val="800"/>
+              </a:spcAft>
+              <a:buSzPct val="100000"/>
+              <a:buChar char="•"/>
+            </a:pPr>
+            <a:r>
+              <a:rPr lang="en-US" sz="2000" dirty="0">
+                <a:solidFill>
+                  <a:srgbClr val="111111"/>
+                </a:solidFill>
+                <a:latin typeface="Calibri" pitchFamily="34" charset="0"/>
+                <a:ea typeface="Calibri" pitchFamily="34" charset="-122"/>
+                <a:cs typeface="Calibri" pitchFamily="34" charset="-120"/>
+              </a:rPr>
+              <a:t>Without the projector (Activity 3): write the temperatures on the board.</a:t>
+            </a:r>
+            <a:endParaRPr lang="en-US" sz="2000" dirty="0"/>
+          </a:p>
+          <a:p>
+            <a:pPr algn="l" marL="342900" indent="-342900">
+              <a:spcAft>
+                <a:spcPts val="800"/>
+              </a:spcAft>
+              <a:buSzPct val="100000"/>
+              <a:buChar char="•"/>
+            </a:pPr>
+            <a:r>
+              <a:rPr lang="en-US" sz="2000" dirty="0">
+                <a:solidFill>
+                  <a:srgbClr val="111111"/>
+                </a:solidFill>
+                <a:latin typeface="Calibri" pitchFamily="34" charset="0"/>
+                <a:ea typeface="Calibri" pitchFamily="34" charset="-122"/>
+                <a:cs typeface="Calibri" pitchFamily="34" charset="-120"/>
+              </a:rPr>
+              <a:t>Without the projector (Activity 4): write the rainfall on the board.</a:t>
+            </a:r>
+            <a:endParaRPr lang="en-US" sz="2000" dirty="0"/>
+          </a:p>
+          <a:p>
+            <a:pPr algn="l" marL="342900" indent="-342900">
+              <a:spcAft>
+                <a:spcPts val="800"/>
+              </a:spcAft>
+              <a:buSzPct val="100000"/>
+              <a:buChar char="•"/>
+            </a:pPr>
+            <a:r>
+              <a:rPr lang="en-US" sz="2000" dirty="0">
+                <a:solidFill>
+                  <a:srgbClr val="111111"/>
+                </a:solidFill>
+                <a:latin typeface="Calibri" pitchFamily="34" charset="0"/>
+                <a:ea typeface="Calibri" pitchFamily="34" charset="-122"/>
+                <a:cs typeface="Calibri" pitchFamily="34" charset="-120"/>
+              </a:rPr>
+              <a:t>Without the projector (Activity 5): describe an afternoon storm.</a:t>
             </a:r>
             <a:endParaRPr lang="en-US" sz="2000" dirty="0"/>
           </a:p>
@@ -20986,7 +20110,7 @@
             <a:pPr algn="ctr"/>
             <a:fld id="{F7021451-1387-4CA6-816F-3879F97B5CBC}" type="slidenum">
               <a:rPr b="1" lang="en-US"/>
-              <a:t>53</a:t>
+              <a:t>50</a:t>
             </a:fld>
             <a:endParaRPr lang="en-US"/>
           </a:p>
@@ -21000,9 +20124,9 @@
 </p:sld>
 </file>
 
-<file path=ppt/slides/slide54.xml><?xml version="1.0" encoding="utf-8"?>
+<file path=ppt/slides/slide51.xml><?xml version="1.0" encoding="utf-8"?>
 <p:sld xmlns:a="http://schemas.openxmlformats.org/drawingml/2006/main" xmlns:r="http://schemas.openxmlformats.org/officeDocument/2006/relationships" xmlns:p="http://schemas.openxmlformats.org/presentationml/2006/main">
-  <p:cSld name="Slide 54">
+  <p:cSld name="Slide 51">
     <p:spTree>
       <p:nvGrpSpPr>
         <p:cNvPr id="1" name=""/>
@@ -21290,7 +20414,7 @@
             <a:pPr algn="ctr"/>
             <a:fld id="{F7021451-1387-4CA6-816F-3879F97B5CBC}" type="slidenum">
               <a:rPr b="1" lang="en-US"/>
-              <a:t>54</a:t>
+              <a:t>51</a:t>
             </a:fld>
             <a:endParaRPr lang="en-US"/>
           </a:p>
@@ -21944,7 +21068,7 @@
                 <a:ea typeface="Times New Roman" pitchFamily="34" charset="-122"/>
                 <a:cs typeface="Times New Roman" pitchFamily="34" charset="-120"/>
               </a:rPr>
-              <a:t>Nadia lives in Garoua. Her cousin in Yaoundé writes to her: "Here it rains in almost every month, the air is hot and wet, and our clothes take a long time to dry." Nadia is surprised, because in Garoua there is no rain for about six months.</a:t>
+              <a:t>Nadia lives in Garoua. Her cousin in Yaoundé writes: "Here it rains in almost every month, and our clothes take a long time to dry." In Garoua, there is no rain for about six months. Nadia asks: "Why is the weather of Yaoundé so different from ours?"</a:t>
             </a:r>
             <a:endParaRPr lang="en-US" sz="4000" dirty="0"/>
           </a:p>

</xml_diff>